<commit_message>
Clean full regeneration — all exports rewritten from scratch
- Deleted old generate_exports.py + regen_emb.py approach
- New print_all.py: single clean script, all 14 chapters in IFMS
  article + 13 chapters in eMB article fully regenerated
- Cache cleared before run
- All 6 files rebuilt: DOCX 39KB, PDF 12KB, PPTX 59KB (IFMS)
  and DOCX 38KB, PDF 9KB, PPTX 52KB (eMB)
- PPTX now has improved cover, facts grid, chapter slides with
  Hindi/English two-column layout, and updated CTA closing slide
  with impunity architecture quote
</commit_message>
<xml_diff>
--- a/artifacts/rajasthan-ifms-crisis/PWD-eMB-Corruption-Investigation.pptx
+++ b/artifacts/rajasthan-ifms-crisis/PWD-eMB-Corruption-Investigation.pptx
@@ -3203,8 +3203,8 @@
         </p:nvSpPr>
         <p:spPr>
           <a:xfrm>
-            <a:off x="365760" y="274320"/>
-            <a:ext cx="11430000" cy="548640"/>
+            <a:off x="365760" y="228600"/>
+            <a:ext cx="11430000" cy="502920"/>
           </a:xfrm>
           <a:prstGeom prst="rect">
             <a:avLst/>
@@ -3219,7 +3219,7 @@
           <a:p>
             <a:pPr algn="ctr"/>
             <a:r>
-              <a:rPr sz="1400" b="1" i="0">
+              <a:rPr sz="1300" b="1" i="0">
                 <a:solidFill>
                   <a:srgbClr val="0D9488"/>
                 </a:solidFill>
@@ -3237,8 +3237,8 @@
         </p:nvSpPr>
         <p:spPr>
           <a:xfrm>
-            <a:off x="365760" y="822960"/>
-            <a:ext cx="11430000" cy="365760"/>
+            <a:off x="365760" y="749808"/>
+            <a:ext cx="11430000" cy="347472"/>
           </a:xfrm>
           <a:prstGeom prst="rect">
             <a:avLst/>
@@ -3253,9 +3253,9 @@
           <a:p>
             <a:pPr algn="ctr"/>
             <a:r>
-              <a:rPr sz="1000" b="0" i="0">
-                <a:solidFill>
-                  <a:srgbClr val="B4BEC8"/>
+              <a:rPr sz="950" b="0" i="0">
+                <a:solidFill>
+                  <a:srgbClr val="AAB9C8"/>
                 </a:solidFill>
               </a:rPr>
               <a:t>खोजी पत्रकारिता  |  INVESTIGATIVE JOURNALISM</a:t>
@@ -3271,7 +3271,7 @@
         </p:nvSpPr>
         <p:spPr>
           <a:xfrm>
-            <a:off x="1371600" y="1280160"/>
+            <a:off x="1371600" y="1188720"/>
             <a:ext cx="9445752" cy="36576"/>
           </a:xfrm>
           <a:prstGeom prst="rect">
@@ -3314,8 +3314,8 @@
         </p:nvSpPr>
         <p:spPr>
           <a:xfrm>
-            <a:off x="548640" y="1463040"/>
-            <a:ext cx="11064240" cy="1097280"/>
+            <a:off x="457200" y="1325880"/>
+            <a:ext cx="11274552" cy="1051560"/>
           </a:xfrm>
           <a:prstGeom prst="rect">
             <a:avLst/>
@@ -3330,7 +3330,7 @@
           <a:p>
             <a:pPr algn="ctr"/>
             <a:r>
-              <a:rPr sz="3200" b="1" i="0">
+              <a:rPr sz="3000" b="1" i="0">
                 <a:solidFill>
                   <a:srgbClr val="FFFFFF"/>
                 </a:solidFill>
@@ -3348,8 +3348,8 @@
         </p:nvSpPr>
         <p:spPr>
           <a:xfrm>
-            <a:off x="548640" y="2651760"/>
-            <a:ext cx="11064240" cy="731520"/>
+            <a:off x="457200" y="2468880"/>
+            <a:ext cx="11274552" cy="685800"/>
           </a:xfrm>
           <a:prstGeom prst="rect">
             <a:avLst/>
@@ -3364,7 +3364,7 @@
           <a:p>
             <a:pPr algn="ctr"/>
             <a:r>
-              <a:rPr sz="1800" b="1" i="0">
+              <a:rPr sz="1600" b="1" i="0">
                 <a:solidFill>
                   <a:srgbClr val="A0C8DC"/>
                 </a:solidFill>
@@ -3382,8 +3382,8 @@
         </p:nvSpPr>
         <p:spPr>
           <a:xfrm>
-            <a:off x="548640" y="3520440"/>
-            <a:ext cx="11064240" cy="548640"/>
+            <a:off x="457200" y="3291840"/>
+            <a:ext cx="11274552" cy="502920"/>
           </a:xfrm>
           <a:prstGeom prst="rect">
             <a:avLst/>
@@ -3398,12 +3398,12 @@
           <a:p>
             <a:pPr algn="ctr"/>
             <a:r>
-              <a:rPr sz="1100" b="0" i="1">
-                <a:solidFill>
-                  <a:srgbClr val="B4BEB4"/>
+              <a:rPr sz="1000" b="0" i="1">
+                <a:solidFill>
+                  <a:srgbClr val="AFB9AF"/>
                 </a:solidFill>
               </a:rPr>
-              <a:t>eMB Abstract, Bitumen CRC Fraud और Missing QC Records की सम्पूर्ण खोजी पड़ताल</a:t>
+              <a:t>eMB Abstract · Bitumen CRC Fraud · 5 Fraud Pathways · Missing QC Records · No Contractor Ledger · Dormant EMD/SD/Dep-V · Rescinded Contracts · Recovery Portal नहीं</a:t>
             </a:r>
           </a:p>
         </p:txBody>
@@ -3416,8 +3416,8 @@
         </p:nvSpPr>
         <p:spPr>
           <a:xfrm>
-            <a:off x="548640" y="4069080"/>
-            <a:ext cx="11064240" cy="548640"/>
+            <a:off x="457200" y="3822191"/>
+            <a:ext cx="11274552" cy="502920"/>
           </a:xfrm>
           <a:prstGeom prst="rect">
             <a:avLst/>
@@ -3432,12 +3432,12 @@
           <a:p>
             <a:pPr algn="ctr"/>
             <a:r>
-              <a:rPr sz="1000" b="0" i="1">
-                <a:solidFill>
-                  <a:srgbClr val="A0AFA5"/>
+              <a:rPr sz="950" b="0" i="1">
+                <a:solidFill>
+                  <a:srgbClr val="9BAAA0"/>
                 </a:solidFill>
               </a:rPr>
-              <a:t>How abstract-only e-MBs, missing Bitumen CRCs and absent QC records enable systematic road fraud</a:t>
+              <a:t>A complete investigative expose of PWD road works corruption enabled by absent digital accountability</a:t>
             </a:r>
           </a:p>
         </p:txBody>
@@ -3450,7 +3450,7 @@
         </p:nvSpPr>
         <p:spPr>
           <a:xfrm>
-            <a:off x="1371600" y="4709160"/>
+            <a:off x="1371600" y="4480560"/>
             <a:ext cx="9445752" cy="36576"/>
           </a:xfrm>
           <a:prstGeom prst="rect">
@@ -3493,8 +3493,8 @@
         </p:nvSpPr>
         <p:spPr>
           <a:xfrm>
-            <a:off x="365760" y="4846320"/>
-            <a:ext cx="11430000" cy="365760"/>
+            <a:off x="365760" y="4617720"/>
+            <a:ext cx="11430000" cy="347472"/>
           </a:xfrm>
           <a:prstGeom prst="rect">
             <a:avLst/>
@@ -3509,9 +3509,9 @@
           <a:p>
             <a:pPr algn="ctr"/>
             <a:r>
-              <a:rPr sz="900" b="0" i="0">
-                <a:solidFill>
-                  <a:srgbClr val="788C96"/>
+              <a:rPr sz="850" b="0" i="0">
+                <a:solidFill>
+                  <a:srgbClr val="6E8291"/>
                 </a:solidFill>
               </a:rPr>
               <a:t>जन संवाददाता | Jan Samvaddaata  •  6 August 2026  •  PWD Roads &amp; Infrastructure Bureau, Rajasthan</a:t>
@@ -3528,6 +3528,456 @@
 </file>
 
 <file path=ppt/slides/slide10.xml><?xml version="1.0" encoding="utf-8"?>
+<p:sld xmlns:a="http://schemas.openxmlformats.org/drawingml/2006/main" xmlns:p="http://schemas.openxmlformats.org/presentationml/2006/main" xmlns:r="http://schemas.openxmlformats.org/officeDocument/2006/relationships">
+  <p:cSld>
+    <p:bg>
+      <p:bgPr>
+        <a:solidFill>
+          <a:srgbClr val="281805"/>
+        </a:solidFill>
+        <a:effectLst/>
+      </p:bgPr>
+    </p:bg>
+    <p:spTree>
+      <p:nvGrpSpPr>
+        <p:cNvPr id="1" name=""/>
+        <p:cNvGrpSpPr/>
+        <p:nvPr/>
+      </p:nvGrpSpPr>
+      <p:grpSpPr/>
+      <p:sp>
+        <p:nvSpPr>
+          <p:cNvPr id="2" name="Rectangle 1"/>
+          <p:cNvSpPr/>
+          <p:nvPr/>
+        </p:nvSpPr>
+        <p:spPr>
+          <a:xfrm>
+            <a:off x="0" y="0"/>
+            <a:ext cx="12188952" cy="64008"/>
+          </a:xfrm>
+          <a:prstGeom prst="rect">
+            <a:avLst/>
+          </a:prstGeom>
+          <a:solidFill>
+            <a:srgbClr val="0D9488"/>
+          </a:solidFill>
+          <a:ln>
+            <a:noFill/>
+          </a:ln>
+        </p:spPr>
+        <p:style>
+          <a:lnRef idx="1">
+            <a:schemeClr val="accent1"/>
+          </a:lnRef>
+          <a:fillRef idx="3">
+            <a:schemeClr val="accent1"/>
+          </a:fillRef>
+          <a:effectRef idx="2">
+            <a:schemeClr val="accent1"/>
+          </a:effectRef>
+          <a:fontRef idx="minor">
+            <a:schemeClr val="lt1"/>
+          </a:fontRef>
+        </p:style>
+        <p:txBody>
+          <a:bodyPr rtlCol="0" anchor="ctr"/>
+          <a:lstStyle/>
+          <a:p>
+            <a:pPr algn="ctr"/>
+          </a:p>
+        </p:txBody>
+      </p:sp>
+      <p:sp>
+        <p:nvSpPr>
+          <p:cNvPr id="3" name="Rectangle 2"/>
+          <p:cNvSpPr/>
+          <p:nvPr/>
+        </p:nvSpPr>
+        <p:spPr>
+          <a:xfrm>
+            <a:off x="0" y="6793992"/>
+            <a:ext cx="12188952" cy="64008"/>
+          </a:xfrm>
+          <a:prstGeom prst="rect">
+            <a:avLst/>
+          </a:prstGeom>
+          <a:solidFill>
+            <a:srgbClr val="0D9488"/>
+          </a:solidFill>
+          <a:ln>
+            <a:noFill/>
+          </a:ln>
+        </p:spPr>
+        <p:style>
+          <a:lnRef idx="1">
+            <a:schemeClr val="accent1"/>
+          </a:lnRef>
+          <a:fillRef idx="3">
+            <a:schemeClr val="accent1"/>
+          </a:fillRef>
+          <a:effectRef idx="2">
+            <a:schemeClr val="accent1"/>
+          </a:effectRef>
+          <a:fontRef idx="minor">
+            <a:schemeClr val="lt1"/>
+          </a:fontRef>
+        </p:style>
+        <p:txBody>
+          <a:bodyPr rtlCol="0" anchor="ctr"/>
+          <a:lstStyle/>
+          <a:p>
+            <a:pPr algn="ctr"/>
+          </a:p>
+        </p:txBody>
+      </p:sp>
+      <p:sp>
+        <p:nvSpPr>
+          <p:cNvPr id="4" name="Rectangle 3"/>
+          <p:cNvSpPr/>
+          <p:nvPr/>
+        </p:nvSpPr>
+        <p:spPr>
+          <a:xfrm>
+            <a:off x="274320" y="137160"/>
+            <a:ext cx="1005840" cy="402336"/>
+          </a:xfrm>
+          <a:prstGeom prst="rect">
+            <a:avLst/>
+          </a:prstGeom>
+          <a:solidFill>
+            <a:srgbClr val="0D9488"/>
+          </a:solidFill>
+          <a:ln>
+            <a:noFill/>
+          </a:ln>
+        </p:spPr>
+        <p:style>
+          <a:lnRef idx="1">
+            <a:schemeClr val="accent1"/>
+          </a:lnRef>
+          <a:fillRef idx="3">
+            <a:schemeClr val="accent1"/>
+          </a:fillRef>
+          <a:effectRef idx="2">
+            <a:schemeClr val="accent1"/>
+          </a:effectRef>
+          <a:fontRef idx="minor">
+            <a:schemeClr val="lt1"/>
+          </a:fontRef>
+        </p:style>
+        <p:txBody>
+          <a:bodyPr rtlCol="0" anchor="ctr"/>
+          <a:lstStyle/>
+          <a:p>
+            <a:pPr algn="ctr"/>
+          </a:p>
+        </p:txBody>
+      </p:sp>
+      <p:sp>
+        <p:nvSpPr>
+          <p:cNvPr id="5" name="TextBox 4"/>
+          <p:cNvSpPr txBox="1"/>
+          <p:nvPr/>
+        </p:nvSpPr>
+        <p:spPr>
+          <a:xfrm>
+            <a:off x="274320" y="137160"/>
+            <a:ext cx="1005840" cy="402336"/>
+          </a:xfrm>
+          <a:prstGeom prst="rect">
+            <a:avLst/>
+          </a:prstGeom>
+          <a:noFill/>
+        </p:spPr>
+        <p:txBody>
+          <a:bodyPr wrap="square">
+            <a:spAutoFit/>
+          </a:bodyPr>
+          <a:lstStyle/>
+          <a:p>
+            <a:pPr algn="ctr"/>
+            <a:r>
+              <a:rPr sz="1000" b="1" i="0">
+                <a:solidFill>
+                  <a:srgbClr val="FFFFFF"/>
+                </a:solidFill>
+              </a:rPr>
+              <a:t>Ch.6C</a:t>
+            </a:r>
+          </a:p>
+        </p:txBody>
+      </p:sp>
+      <p:sp>
+        <p:nvSpPr>
+          <p:cNvPr id="6" name="TextBox 5"/>
+          <p:cNvSpPr txBox="1"/>
+          <p:nvPr/>
+        </p:nvSpPr>
+        <p:spPr>
+          <a:xfrm>
+            <a:off x="1417320" y="109728"/>
+            <a:ext cx="10424160" cy="530352"/>
+          </a:xfrm>
+          <a:prstGeom prst="rect">
+            <a:avLst/>
+          </a:prstGeom>
+          <a:noFill/>
+        </p:spPr>
+        <p:txBody>
+          <a:bodyPr wrap="square">
+            <a:spAutoFit/>
+          </a:bodyPr>
+          <a:lstStyle/>
+          <a:p>
+            <a:pPr algn="l"/>
+            <a:r>
+              <a:rPr sz="1700" b="1" i="0">
+                <a:solidFill>
+                  <a:srgbClr val="FFFFFF"/>
+                </a:solidFill>
+              </a:rPr>
+              <a:t>रद्द अनुबंध — भैरवजी Bridge, Kotada Road, Gannon Dunkerlay</a:t>
+            </a:r>
+          </a:p>
+        </p:txBody>
+      </p:sp>
+      <p:sp>
+        <p:nvSpPr>
+          <p:cNvPr id="7" name="TextBox 6"/>
+          <p:cNvSpPr txBox="1"/>
+          <p:nvPr/>
+        </p:nvSpPr>
+        <p:spPr>
+          <a:xfrm>
+            <a:off x="1417320" y="612648"/>
+            <a:ext cx="10424160" cy="402336"/>
+          </a:xfrm>
+          <a:prstGeom prst="rect">
+            <a:avLst/>
+          </a:prstGeom>
+          <a:noFill/>
+        </p:spPr>
+        <p:txBody>
+          <a:bodyPr wrap="square">
+            <a:spAutoFit/>
+          </a:bodyPr>
+          <a:lstStyle/>
+          <a:p>
+            <a:pPr algn="l"/>
+            <a:r>
+              <a:rPr sz="1150" b="1" i="0">
+                <a:solidFill>
+                  <a:srgbClr val="A0C8DC"/>
+                </a:solidFill>
+              </a:rPr>
+              <a:t>Rescinded Contracts — Bhairavji Bridge, Kotada Road, Gannon Dunkerlay</a:t>
+            </a:r>
+          </a:p>
+        </p:txBody>
+      </p:sp>
+      <p:sp>
+        <p:nvSpPr>
+          <p:cNvPr id="8" name="Rectangle 7"/>
+          <p:cNvSpPr/>
+          <p:nvPr/>
+        </p:nvSpPr>
+        <p:spPr>
+          <a:xfrm>
+            <a:off x="274320" y="1133856"/>
+            <a:ext cx="11640312" cy="27432"/>
+          </a:xfrm>
+          <a:prstGeom prst="rect">
+            <a:avLst/>
+          </a:prstGeom>
+          <a:solidFill>
+            <a:srgbClr val="0D9488"/>
+          </a:solidFill>
+          <a:ln>
+            <a:noFill/>
+          </a:ln>
+        </p:spPr>
+        <p:style>
+          <a:lnRef idx="1">
+            <a:schemeClr val="accent1"/>
+          </a:lnRef>
+          <a:fillRef idx="3">
+            <a:schemeClr val="accent1"/>
+          </a:fillRef>
+          <a:effectRef idx="2">
+            <a:schemeClr val="accent1"/>
+          </a:effectRef>
+          <a:fontRef idx="minor">
+            <a:schemeClr val="lt1"/>
+          </a:fontRef>
+        </p:style>
+        <p:txBody>
+          <a:bodyPr rtlCol="0" anchor="ctr"/>
+          <a:lstStyle/>
+          <a:p>
+            <a:pPr algn="ctr"/>
+          </a:p>
+        </p:txBody>
+      </p:sp>
+      <p:sp>
+        <p:nvSpPr>
+          <p:cNvPr id="9" name="TextBox 8"/>
+          <p:cNvSpPr txBox="1"/>
+          <p:nvPr/>
+        </p:nvSpPr>
+        <p:spPr>
+          <a:xfrm>
+            <a:off x="274320" y="1234440"/>
+            <a:ext cx="5669280" cy="5120640"/>
+          </a:xfrm>
+          <a:prstGeom prst="rect">
+            <a:avLst/>
+          </a:prstGeom>
+          <a:noFill/>
+        </p:spPr>
+        <p:txBody>
+          <a:bodyPr wrap="square">
+            <a:spAutoFit/>
+          </a:bodyPr>
+          <a:lstStyle/>
+          <a:p>
+            <a:pPr algn="l"/>
+            <a:r>
+              <a:rPr sz="1050" b="0" i="0">
+                <a:solidFill>
+                  <a:srgbClr val="DAE0E6"/>
+                </a:solidFill>
+              </a:rPr>
+              <a:t>भैरवजी Bridge, Kotada Road, Gannon Dunkerlay — तीनों में वसूली शून्य। ~200
+rescissions — कोई systematic monitoring नहीं। Blacklist enforce नहीं।</a:t>
+            </a:r>
+          </a:p>
+        </p:txBody>
+      </p:sp>
+      <p:sp>
+        <p:nvSpPr>
+          <p:cNvPr id="10" name="TextBox 9"/>
+          <p:cNvSpPr txBox="1"/>
+          <p:nvPr/>
+        </p:nvSpPr>
+        <p:spPr>
+          <a:xfrm>
+            <a:off x="6217920" y="1234440"/>
+            <a:ext cx="5669280" cy="5120640"/>
+          </a:xfrm>
+          <a:prstGeom prst="rect">
+            <a:avLst/>
+          </a:prstGeom>
+          <a:noFill/>
+        </p:spPr>
+        <p:txBody>
+          <a:bodyPr wrap="square">
+            <a:spAutoFit/>
+          </a:bodyPr>
+          <a:lstStyle/>
+          <a:p>
+            <a:pPr algn="l"/>
+            <a:r>
+              <a:rPr sz="1000" b="0" i="1">
+                <a:solidFill>
+                  <a:srgbClr val="A8B9C3"/>
+                </a:solidFill>
+              </a:rPr>
+              <a:t>Three named cases: Bhairavji Bridge Banswara (rescinded, nil recovery), Kotada
+Road Udaipur (rescinded, nil recovery), Gannon Dunkerlay &amp; Co — established
+firm, contract rescinded, substantial dues unexercised, company walked free.
+~200 rescissions statewide, zero monitoring. Rescission is a paper threat, not
+a financial liability.</a:t>
+            </a:r>
+          </a:p>
+        </p:txBody>
+      </p:sp>
+      <p:sp>
+        <p:nvSpPr>
+          <p:cNvPr id="11" name="Rectangle 10"/>
+          <p:cNvSpPr/>
+          <p:nvPr/>
+        </p:nvSpPr>
+        <p:spPr>
+          <a:xfrm>
+            <a:off x="6035040" y="1234440"/>
+            <a:ext cx="27432" cy="5120640"/>
+          </a:xfrm>
+          <a:prstGeom prst="rect">
+            <a:avLst/>
+          </a:prstGeom>
+          <a:solidFill>
+            <a:srgbClr val="0D9488"/>
+          </a:solidFill>
+          <a:ln>
+            <a:noFill/>
+          </a:ln>
+        </p:spPr>
+        <p:style>
+          <a:lnRef idx="1">
+            <a:schemeClr val="accent1"/>
+          </a:lnRef>
+          <a:fillRef idx="3">
+            <a:schemeClr val="accent1"/>
+          </a:fillRef>
+          <a:effectRef idx="2">
+            <a:schemeClr val="accent1"/>
+          </a:effectRef>
+          <a:fontRef idx="minor">
+            <a:schemeClr val="lt1"/>
+          </a:fontRef>
+        </p:style>
+        <p:txBody>
+          <a:bodyPr rtlCol="0" anchor="ctr"/>
+          <a:lstStyle/>
+          <a:p>
+            <a:pPr algn="ctr"/>
+          </a:p>
+        </p:txBody>
+      </p:sp>
+      <p:sp>
+        <p:nvSpPr>
+          <p:cNvPr id="12" name="TextBox 11"/>
+          <p:cNvSpPr txBox="1"/>
+          <p:nvPr/>
+        </p:nvSpPr>
+        <p:spPr>
+          <a:xfrm>
+            <a:off x="10881360" y="6492240"/>
+            <a:ext cx="1188720" cy="274320"/>
+          </a:xfrm>
+          <a:prstGeom prst="rect">
+            <a:avLst/>
+          </a:prstGeom>
+          <a:noFill/>
+        </p:spPr>
+        <p:txBody>
+          <a:bodyPr wrap="square">
+            <a:spAutoFit/>
+          </a:bodyPr>
+          <a:lstStyle/>
+          <a:p>
+            <a:pPr algn="r"/>
+            <a:r>
+              <a:rPr sz="800" b="0" i="0">
+                <a:solidFill>
+                  <a:srgbClr val="647382"/>
+                </a:solidFill>
+              </a:rPr>
+              <a:t>Slide 10 / 13</a:t>
+            </a:r>
+          </a:p>
+        </p:txBody>
+      </p:sp>
+    </p:spTree>
+  </p:cSld>
+  <p:clrMapOvr>
+    <a:masterClrMapping/>
+  </p:clrMapOvr>
+</p:sld>
+</file>
+
+<file path=ppt/slides/slide11.xml><?xml version="1.0" encoding="utf-8"?>
 <p:sld xmlns:a="http://schemas.openxmlformats.org/drawingml/2006/main" xmlns:p="http://schemas.openxmlformats.org/presentationml/2006/main" xmlns:r="http://schemas.openxmlformats.org/officeDocument/2006/relationships">
   <p:cSld>
     <p:bg>
@@ -3639,8 +4089,8 @@
         </p:nvSpPr>
         <p:spPr>
           <a:xfrm>
-            <a:off x="274320" y="164592"/>
-            <a:ext cx="1005840" cy="411480"/>
+            <a:off x="274320" y="137160"/>
+            <a:ext cx="1005840" cy="402336"/>
           </a:xfrm>
           <a:prstGeom prst="rect">
             <a:avLst/>
@@ -3682,8 +4132,8 @@
         </p:nvSpPr>
         <p:spPr>
           <a:xfrm>
-            <a:off x="274320" y="164592"/>
-            <a:ext cx="1005840" cy="411480"/>
+            <a:off x="274320" y="137160"/>
+            <a:ext cx="1005840" cy="402336"/>
           </a:xfrm>
           <a:prstGeom prst="rect">
             <a:avLst/>
@@ -3698,12 +4148,12 @@
           <a:p>
             <a:pPr algn="ctr"/>
             <a:r>
-              <a:rPr sz="1100" b="1" i="0">
+              <a:rPr sz="1000" b="1" i="0">
                 <a:solidFill>
                   <a:srgbClr val="FFFFFF"/>
                 </a:solidFill>
               </a:rPr>
-              <a:t>Ch.6C</a:t>
+              <a:t>Ch.6D</a:t>
             </a:r>
           </a:p>
         </p:txBody>
@@ -3716,8 +4166,8 @@
         </p:nvSpPr>
         <p:spPr>
           <a:xfrm>
-            <a:off x="1417320" y="137160"/>
-            <a:ext cx="10424160" cy="548640"/>
+            <a:off x="1417320" y="109728"/>
+            <a:ext cx="10424160" cy="530352"/>
           </a:xfrm>
           <a:prstGeom prst="rect">
             <a:avLst/>
@@ -3732,12 +4182,12 @@
           <a:p>
             <a:pPr algn="l"/>
             <a:r>
-              <a:rPr sz="1800" b="1" i="0">
+              <a:rPr sz="1700" b="1" i="0">
                 <a:solidFill>
                   <a:srgbClr val="FFFFFF"/>
                 </a:solidFill>
               </a:rPr>
-              <a:t>रद्द अनुबंध — Gannon Dunkerlay, Bhairavji, Kotada</a:t>
+              <a:t>Recovery Portal नहीं, Legal Pursuit नहीं — Impunity का Architecture</a:t>
             </a:r>
           </a:p>
         </p:txBody>
@@ -3750,8 +4200,8 @@
         </p:nvSpPr>
         <p:spPr>
           <a:xfrm>
-            <a:off x="1417320" y="658368"/>
-            <a:ext cx="10424160" cy="411480"/>
+            <a:off x="1417320" y="612648"/>
+            <a:ext cx="10424160" cy="402336"/>
           </a:xfrm>
           <a:prstGeom prst="rect">
             <a:avLst/>
@@ -3766,12 +4216,12 @@
           <a:p>
             <a:pPr algn="l"/>
             <a:r>
-              <a:rPr sz="1200" b="1" i="0">
+              <a:rPr sz="1150" b="1" i="0">
                 <a:solidFill>
                   <a:srgbClr val="A0C8DC"/>
                 </a:solidFill>
               </a:rPr>
-              <a:t>Rescinded Contracts — Zero Recovery (Bhairavji, Kotada, Gannon Dunkerlay)</a:t>
+              <a:t>Why No Recovery Portal? Why No Legal Pursuit? — Architecture of Impunity</a:t>
             </a:r>
           </a:p>
         </p:txBody>
@@ -3784,7 +4234,7 @@
         </p:nvSpPr>
         <p:spPr>
           <a:xfrm>
-            <a:off x="274320" y="1170432"/>
+            <a:off x="274320" y="1133856"/>
             <a:ext cx="11640312" cy="27432"/>
           </a:xfrm>
           <a:prstGeom prst="rect">
@@ -3827,8 +4277,8 @@
         </p:nvSpPr>
         <p:spPr>
           <a:xfrm>
-            <a:off x="274320" y="1280160"/>
-            <a:ext cx="5669280" cy="5029200"/>
+            <a:off x="274320" y="1234440"/>
+            <a:ext cx="5669280" cy="5120640"/>
           </a:xfrm>
           <a:prstGeom prst="rect">
             <a:avLst/>
@@ -3843,13 +4293,14 @@
           <a:p>
             <a:pPr algn="l"/>
             <a:r>
-              <a:rPr sz="1100" b="0" i="0">
-                <a:solidFill>
-                  <a:srgbClr val="DCE1E6"/>
+              <a:rPr sz="1050" b="0" i="0">
+                <a:solidFill>
+                  <a:srgbClr val="DAE0E6"/>
                 </a:solidFill>
               </a:rPr>
-              <a:t>भैरवजी Bridge, Kotada Road, Gannon Dunkerlay — तीनों में वसूली शून्य। ~200
-rescissions — कोई systematic monitoring नहीं।</a:t>
+              <a:t>Recovery Portal 15 वर्षों में नहीं — visibility = accountability से बचाव।
+Legal pursuit नहीं — Negligence या Complicity। Limitation expire हो रहे हैं।
+Framework: Portal 90 days, Notice 30 days, Register, Alerts, ACB referral।</a:t>
             </a:r>
           </a:p>
         </p:txBody>
@@ -3862,8 +4313,8 @@
         </p:nvSpPr>
         <p:spPr>
           <a:xfrm>
-            <a:off x="6217920" y="1280160"/>
-            <a:ext cx="5669280" cy="5029200"/>
+            <a:off x="6217920" y="1234440"/>
+            <a:ext cx="5669280" cy="5120640"/>
           </a:xfrm>
           <a:prstGeom prst="rect">
             <a:avLst/>
@@ -3878,14 +4329,18 @@
           <a:p>
             <a:pPr algn="l"/>
             <a:r>
-              <a:rPr sz="1050" b="0" i="1">
-                <a:solidFill>
-                  <a:srgbClr val="AAB9C3"/>
+              <a:rPr sz="1000" b="0" i="1">
+                <a:solidFill>
+                  <a:srgbClr val="A8B9C3"/>
                 </a:solidFill>
               </a:rPr>
-              <a:t>Bhairavji Bridge Banswara, Kotada Road Udaipur, Gannon Dunkerlay — three named
-cases, nil recovery. ~200 rescissions statewide, zero monitoring. Paper threat,
-no financial consequence.</a:t>
+              <a:t>Q1: Recovery Portal not built in 15 years — because it would make every non-
+recovery visible and attributable to a named officer. Q2: No legal pursuit
+because of either Gross Negligence or Complicity — the same officer who
+processed payments is the officer who refuses to collect. Limitation periods
+expiring unnoticed. Five-point framework: Portal in 90 days; legal notice in
+30 days; litigation register; limitation alerts; same-officer overlap = ACB
+referral.</a:t>
             </a:r>
           </a:p>
         </p:txBody>
@@ -3898,8 +4353,8 @@
         </p:nvSpPr>
         <p:spPr>
           <a:xfrm>
-            <a:off x="6035040" y="1280160"/>
-            <a:ext cx="27432" cy="5029200"/>
+            <a:off x="6035040" y="1234440"/>
+            <a:ext cx="27432" cy="5120640"/>
           </a:xfrm>
           <a:prstGeom prst="rect">
             <a:avLst/>
@@ -3941,8 +4396,8 @@
         </p:nvSpPr>
         <p:spPr>
           <a:xfrm>
-            <a:off x="10972800" y="6492240"/>
-            <a:ext cx="1097280" cy="274320"/>
+            <a:off x="10881360" y="6492240"/>
+            <a:ext cx="1188720" cy="274320"/>
           </a:xfrm>
           <a:prstGeom prst="rect">
             <a:avLst/>
@@ -3959,462 +4414,10 @@
             <a:r>
               <a:rPr sz="800" b="0" i="0">
                 <a:solidFill>
-                  <a:srgbClr val="64788C"/>
+                  <a:srgbClr val="647382"/>
                 </a:solidFill>
               </a:rPr>
-              <a:t>10 / 13</a:t>
-            </a:r>
-          </a:p>
-        </p:txBody>
-      </p:sp>
-    </p:spTree>
-  </p:cSld>
-  <p:clrMapOvr>
-    <a:masterClrMapping/>
-  </p:clrMapOvr>
-</p:sld>
-</file>
-
-<file path=ppt/slides/slide11.xml><?xml version="1.0" encoding="utf-8"?>
-<p:sld xmlns:a="http://schemas.openxmlformats.org/drawingml/2006/main" xmlns:p="http://schemas.openxmlformats.org/presentationml/2006/main" xmlns:r="http://schemas.openxmlformats.org/officeDocument/2006/relationships">
-  <p:cSld>
-    <p:bg>
-      <p:bgPr>
-        <a:solidFill>
-          <a:srgbClr val="1A2E50"/>
-        </a:solidFill>
-        <a:effectLst/>
-      </p:bgPr>
-    </p:bg>
-    <p:spTree>
-      <p:nvGrpSpPr>
-        <p:cNvPr id="1" name=""/>
-        <p:cNvGrpSpPr/>
-        <p:nvPr/>
-      </p:nvGrpSpPr>
-      <p:grpSpPr/>
-      <p:sp>
-        <p:nvSpPr>
-          <p:cNvPr id="2" name="Rectangle 1"/>
-          <p:cNvSpPr/>
-          <p:nvPr/>
-        </p:nvSpPr>
-        <p:spPr>
-          <a:xfrm>
-            <a:off x="0" y="0"/>
-            <a:ext cx="12188952" cy="64008"/>
-          </a:xfrm>
-          <a:prstGeom prst="rect">
-            <a:avLst/>
-          </a:prstGeom>
-          <a:solidFill>
-            <a:srgbClr val="0D9488"/>
-          </a:solidFill>
-          <a:ln>
-            <a:noFill/>
-          </a:ln>
-        </p:spPr>
-        <p:style>
-          <a:lnRef idx="1">
-            <a:schemeClr val="accent1"/>
-          </a:lnRef>
-          <a:fillRef idx="3">
-            <a:schemeClr val="accent1"/>
-          </a:fillRef>
-          <a:effectRef idx="2">
-            <a:schemeClr val="accent1"/>
-          </a:effectRef>
-          <a:fontRef idx="minor">
-            <a:schemeClr val="lt1"/>
-          </a:fontRef>
-        </p:style>
-        <p:txBody>
-          <a:bodyPr rtlCol="0" anchor="ctr"/>
-          <a:lstStyle/>
-          <a:p>
-            <a:pPr algn="ctr"/>
-          </a:p>
-        </p:txBody>
-      </p:sp>
-      <p:sp>
-        <p:nvSpPr>
-          <p:cNvPr id="3" name="Rectangle 2"/>
-          <p:cNvSpPr/>
-          <p:nvPr/>
-        </p:nvSpPr>
-        <p:spPr>
-          <a:xfrm>
-            <a:off x="0" y="6793992"/>
-            <a:ext cx="12188952" cy="64008"/>
-          </a:xfrm>
-          <a:prstGeom prst="rect">
-            <a:avLst/>
-          </a:prstGeom>
-          <a:solidFill>
-            <a:srgbClr val="0D9488"/>
-          </a:solidFill>
-          <a:ln>
-            <a:noFill/>
-          </a:ln>
-        </p:spPr>
-        <p:style>
-          <a:lnRef idx="1">
-            <a:schemeClr val="accent1"/>
-          </a:lnRef>
-          <a:fillRef idx="3">
-            <a:schemeClr val="accent1"/>
-          </a:fillRef>
-          <a:effectRef idx="2">
-            <a:schemeClr val="accent1"/>
-          </a:effectRef>
-          <a:fontRef idx="minor">
-            <a:schemeClr val="lt1"/>
-          </a:fontRef>
-        </p:style>
-        <p:txBody>
-          <a:bodyPr rtlCol="0" anchor="ctr"/>
-          <a:lstStyle/>
-          <a:p>
-            <a:pPr algn="ctr"/>
-          </a:p>
-        </p:txBody>
-      </p:sp>
-      <p:sp>
-        <p:nvSpPr>
-          <p:cNvPr id="4" name="Rectangle 3"/>
-          <p:cNvSpPr/>
-          <p:nvPr/>
-        </p:nvSpPr>
-        <p:spPr>
-          <a:xfrm>
-            <a:off x="274320" y="164592"/>
-            <a:ext cx="1005840" cy="411480"/>
-          </a:xfrm>
-          <a:prstGeom prst="rect">
-            <a:avLst/>
-          </a:prstGeom>
-          <a:solidFill>
-            <a:srgbClr val="0D9488"/>
-          </a:solidFill>
-          <a:ln>
-            <a:noFill/>
-          </a:ln>
-        </p:spPr>
-        <p:style>
-          <a:lnRef idx="1">
-            <a:schemeClr val="accent1"/>
-          </a:lnRef>
-          <a:fillRef idx="3">
-            <a:schemeClr val="accent1"/>
-          </a:fillRef>
-          <a:effectRef idx="2">
-            <a:schemeClr val="accent1"/>
-          </a:effectRef>
-          <a:fontRef idx="minor">
-            <a:schemeClr val="lt1"/>
-          </a:fontRef>
-        </p:style>
-        <p:txBody>
-          <a:bodyPr rtlCol="0" anchor="ctr"/>
-          <a:lstStyle/>
-          <a:p>
-            <a:pPr algn="ctr"/>
-          </a:p>
-        </p:txBody>
-      </p:sp>
-      <p:sp>
-        <p:nvSpPr>
-          <p:cNvPr id="5" name="TextBox 4"/>
-          <p:cNvSpPr txBox="1"/>
-          <p:nvPr/>
-        </p:nvSpPr>
-        <p:spPr>
-          <a:xfrm>
-            <a:off x="274320" y="164592"/>
-            <a:ext cx="1005840" cy="411480"/>
-          </a:xfrm>
-          <a:prstGeom prst="rect">
-            <a:avLst/>
-          </a:prstGeom>
-          <a:noFill/>
-        </p:spPr>
-        <p:txBody>
-          <a:bodyPr wrap="square">
-            <a:spAutoFit/>
-          </a:bodyPr>
-          <a:lstStyle/>
-          <a:p>
-            <a:pPr algn="ctr"/>
-            <a:r>
-              <a:rPr sz="1100" b="1" i="0">
-                <a:solidFill>
-                  <a:srgbClr val="FFFFFF"/>
-                </a:solidFill>
-              </a:rPr>
-              <a:t>Ch.6D</a:t>
-            </a:r>
-          </a:p>
-        </p:txBody>
-      </p:sp>
-      <p:sp>
-        <p:nvSpPr>
-          <p:cNvPr id="6" name="TextBox 5"/>
-          <p:cNvSpPr txBox="1"/>
-          <p:nvPr/>
-        </p:nvSpPr>
-        <p:spPr>
-          <a:xfrm>
-            <a:off x="1417320" y="137160"/>
-            <a:ext cx="10424160" cy="548640"/>
-          </a:xfrm>
-          <a:prstGeom prst="rect">
-            <a:avLst/>
-          </a:prstGeom>
-          <a:noFill/>
-        </p:spPr>
-        <p:txBody>
-          <a:bodyPr wrap="square">
-            <a:spAutoFit/>
-          </a:bodyPr>
-          <a:lstStyle/>
-          <a:p>
-            <a:pPr algn="l"/>
-            <a:r>
-              <a:rPr sz="1800" b="1" i="0">
-                <a:solidFill>
-                  <a:srgbClr val="FFFFFF"/>
-                </a:solidFill>
-              </a:rPr>
-              <a:t>Recovery Portal नहीं, Legal Pursuit नहीं — Impunity का Architecture</a:t>
-            </a:r>
-          </a:p>
-        </p:txBody>
-      </p:sp>
-      <p:sp>
-        <p:nvSpPr>
-          <p:cNvPr id="7" name="TextBox 6"/>
-          <p:cNvSpPr txBox="1"/>
-          <p:nvPr/>
-        </p:nvSpPr>
-        <p:spPr>
-          <a:xfrm>
-            <a:off x="1417320" y="658368"/>
-            <a:ext cx="10424160" cy="411480"/>
-          </a:xfrm>
-          <a:prstGeom prst="rect">
-            <a:avLst/>
-          </a:prstGeom>
-          <a:noFill/>
-        </p:spPr>
-        <p:txBody>
-          <a:bodyPr wrap="square">
-            <a:spAutoFit/>
-          </a:bodyPr>
-          <a:lstStyle/>
-          <a:p>
-            <a:pPr algn="l"/>
-            <a:r>
-              <a:rPr sz="1200" b="1" i="0">
-                <a:solidFill>
-                  <a:srgbClr val="A0C8DC"/>
-                </a:solidFill>
-              </a:rPr>
-              <a:t>Why No Recovery Portal? Why No Legal Pursuit? — Architecture of Impunity</a:t>
-            </a:r>
-          </a:p>
-        </p:txBody>
-      </p:sp>
-      <p:sp>
-        <p:nvSpPr>
-          <p:cNvPr id="8" name="Rectangle 7"/>
-          <p:cNvSpPr/>
-          <p:nvPr/>
-        </p:nvSpPr>
-        <p:spPr>
-          <a:xfrm>
-            <a:off x="274320" y="1170432"/>
-            <a:ext cx="11640312" cy="27432"/>
-          </a:xfrm>
-          <a:prstGeom prst="rect">
-            <a:avLst/>
-          </a:prstGeom>
-          <a:solidFill>
-            <a:srgbClr val="0D9488"/>
-          </a:solidFill>
-          <a:ln>
-            <a:noFill/>
-          </a:ln>
-        </p:spPr>
-        <p:style>
-          <a:lnRef idx="1">
-            <a:schemeClr val="accent1"/>
-          </a:lnRef>
-          <a:fillRef idx="3">
-            <a:schemeClr val="accent1"/>
-          </a:fillRef>
-          <a:effectRef idx="2">
-            <a:schemeClr val="accent1"/>
-          </a:effectRef>
-          <a:fontRef idx="minor">
-            <a:schemeClr val="lt1"/>
-          </a:fontRef>
-        </p:style>
-        <p:txBody>
-          <a:bodyPr rtlCol="0" anchor="ctr"/>
-          <a:lstStyle/>
-          <a:p>
-            <a:pPr algn="ctr"/>
-          </a:p>
-        </p:txBody>
-      </p:sp>
-      <p:sp>
-        <p:nvSpPr>
-          <p:cNvPr id="9" name="TextBox 8"/>
-          <p:cNvSpPr txBox="1"/>
-          <p:nvPr/>
-        </p:nvSpPr>
-        <p:spPr>
-          <a:xfrm>
-            <a:off x="274320" y="1280160"/>
-            <a:ext cx="5669280" cy="5029200"/>
-          </a:xfrm>
-          <a:prstGeom prst="rect">
-            <a:avLst/>
-          </a:prstGeom>
-          <a:noFill/>
-        </p:spPr>
-        <p:txBody>
-          <a:bodyPr wrap="square">
-            <a:spAutoFit/>
-          </a:bodyPr>
-          <a:lstStyle/>
-          <a:p>
-            <a:pPr algn="l"/>
-            <a:r>
-              <a:rPr sz="1100" b="0" i="0">
-                <a:solidFill>
-                  <a:srgbClr val="DCE1E6"/>
-                </a:solidFill>
-              </a:rPr>
-              <a:t>Recovery Portal 15 वर्षों में नहीं बना — accountability से बचने के लिए। Legal
-pursuit नहीं — Negligence या Complicity। Limitation periods expire हो रहे हैं।
-5-point framework: Portal 90 days, Legal notice 30 days, Litigation register,
-Limitation alerts, ACB referral।</a:t>
-            </a:r>
-          </a:p>
-        </p:txBody>
-      </p:sp>
-      <p:sp>
-        <p:nvSpPr>
-          <p:cNvPr id="10" name="TextBox 9"/>
-          <p:cNvSpPr txBox="1"/>
-          <p:nvPr/>
-        </p:nvSpPr>
-        <p:spPr>
-          <a:xfrm>
-            <a:off x="6217920" y="1280160"/>
-            <a:ext cx="5669280" cy="5029200"/>
-          </a:xfrm>
-          <a:prstGeom prst="rect">
-            <a:avLst/>
-          </a:prstGeom>
-          <a:noFill/>
-        </p:spPr>
-        <p:txBody>
-          <a:bodyPr wrap="square">
-            <a:spAutoFit/>
-          </a:bodyPr>
-          <a:lstStyle/>
-          <a:p>
-            <a:pPr algn="l"/>
-            <a:r>
-              <a:rPr sz="1050" b="0" i="1">
-                <a:solidFill>
-                  <a:srgbClr val="AAB9C3"/>
-                </a:solidFill>
-              </a:rPr>
-              <a:t>Q1: Why no Digitised Recovery Portal in 15 years despite full technical
-capacity? Because visibility means accountability — which the system avoids. Q2:
-Why no legal pursuit? Either Gross Negligence or Complicity — same officer who
-paid refuses to collect. Limitation periods expiring unnoticed. Five-point
-framework required.</a:t>
-            </a:r>
-          </a:p>
-        </p:txBody>
-      </p:sp>
-      <p:sp>
-        <p:nvSpPr>
-          <p:cNvPr id="11" name="Rectangle 10"/>
-          <p:cNvSpPr/>
-          <p:nvPr/>
-        </p:nvSpPr>
-        <p:spPr>
-          <a:xfrm>
-            <a:off x="6035040" y="1280160"/>
-            <a:ext cx="27432" cy="5029200"/>
-          </a:xfrm>
-          <a:prstGeom prst="rect">
-            <a:avLst/>
-          </a:prstGeom>
-          <a:solidFill>
-            <a:srgbClr val="0D9488"/>
-          </a:solidFill>
-          <a:ln>
-            <a:noFill/>
-          </a:ln>
-        </p:spPr>
-        <p:style>
-          <a:lnRef idx="1">
-            <a:schemeClr val="accent1"/>
-          </a:lnRef>
-          <a:fillRef idx="3">
-            <a:schemeClr val="accent1"/>
-          </a:fillRef>
-          <a:effectRef idx="2">
-            <a:schemeClr val="accent1"/>
-          </a:effectRef>
-          <a:fontRef idx="minor">
-            <a:schemeClr val="lt1"/>
-          </a:fontRef>
-        </p:style>
-        <p:txBody>
-          <a:bodyPr rtlCol="0" anchor="ctr"/>
-          <a:lstStyle/>
-          <a:p>
-            <a:pPr algn="ctr"/>
-          </a:p>
-        </p:txBody>
-      </p:sp>
-      <p:sp>
-        <p:nvSpPr>
-          <p:cNvPr id="12" name="TextBox 11"/>
-          <p:cNvSpPr txBox="1"/>
-          <p:nvPr/>
-        </p:nvSpPr>
-        <p:spPr>
-          <a:xfrm>
-            <a:off x="10972800" y="6492240"/>
-            <a:ext cx="1097280" cy="274320"/>
-          </a:xfrm>
-          <a:prstGeom prst="rect">
-            <a:avLst/>
-          </a:prstGeom>
-          <a:noFill/>
-        </p:spPr>
-        <p:txBody>
-          <a:bodyPr wrap="square">
-            <a:spAutoFit/>
-          </a:bodyPr>
-          <a:lstStyle/>
-          <a:p>
-            <a:pPr algn="r"/>
-            <a:r>
-              <a:rPr sz="800" b="0" i="0">
-                <a:solidFill>
-                  <a:srgbClr val="64788C"/>
-                </a:solidFill>
-              </a:rPr>
-              <a:t>11 / 13</a:t>
+              <a:t>Slide 11 / 13</a:t>
             </a:r>
           </a:p>
         </p:txBody>
@@ -4539,8 +4542,8 @@
         </p:nvSpPr>
         <p:spPr>
           <a:xfrm>
-            <a:off x="274320" y="164592"/>
-            <a:ext cx="1005840" cy="411480"/>
+            <a:off x="274320" y="137160"/>
+            <a:ext cx="1005840" cy="402336"/>
           </a:xfrm>
           <a:prstGeom prst="rect">
             <a:avLst/>
@@ -4582,8 +4585,8 @@
         </p:nvSpPr>
         <p:spPr>
           <a:xfrm>
-            <a:off x="274320" y="164592"/>
-            <a:ext cx="1005840" cy="411480"/>
+            <a:off x="274320" y="137160"/>
+            <a:ext cx="1005840" cy="402336"/>
           </a:xfrm>
           <a:prstGeom prst="rect">
             <a:avLst/>
@@ -4598,7 +4601,7 @@
           <a:p>
             <a:pPr algn="ctr"/>
             <a:r>
-              <a:rPr sz="1100" b="1" i="0">
+              <a:rPr sz="1000" b="1" i="0">
                 <a:solidFill>
                   <a:srgbClr val="FFFFFF"/>
                 </a:solidFill>
@@ -4616,8 +4619,8 @@
         </p:nvSpPr>
         <p:spPr>
           <a:xfrm>
-            <a:off x="1417320" y="137160"/>
-            <a:ext cx="10424160" cy="548640"/>
+            <a:off x="1417320" y="109728"/>
+            <a:ext cx="10424160" cy="530352"/>
           </a:xfrm>
           <a:prstGeom prst="rect">
             <a:avLst/>
@@ -4632,12 +4635,12 @@
           <a:p>
             <a:pPr algn="l"/>
             <a:r>
-              <a:rPr sz="1800" b="1" i="0">
+              <a:rPr sz="1700" b="1" i="0">
                 <a:solidFill>
                   <a:srgbClr val="FFFFFF"/>
                 </a:solidFill>
               </a:rPr>
-              <a:t>छह Minimum Corrective Actions — तत्काल</a:t>
+              <a:t>सात Minimum Corrective Actions — तत्काल</a:t>
             </a:r>
           </a:p>
         </p:txBody>
@@ -4650,8 +4653,8 @@
         </p:nvSpPr>
         <p:spPr>
           <a:xfrm>
-            <a:off x="1417320" y="658368"/>
-            <a:ext cx="10424160" cy="411480"/>
+            <a:off x="1417320" y="612648"/>
+            <a:ext cx="10424160" cy="402336"/>
           </a:xfrm>
           <a:prstGeom prst="rect">
             <a:avLst/>
@@ -4666,12 +4669,12 @@
           <a:p>
             <a:pPr algn="l"/>
             <a:r>
-              <a:rPr sz="1200" b="1" i="0">
+              <a:rPr sz="1150" b="1" i="0">
                 <a:solidFill>
                   <a:srgbClr val="A0C8DC"/>
                 </a:solidFill>
               </a:rPr>
-              <a:t>Six Minimum Corrective Actions — Immediate</a:t>
+              <a:t>Seven Minimum Corrective Actions — Immediate</a:t>
             </a:r>
           </a:p>
         </p:txBody>
@@ -4684,7 +4687,7 @@
         </p:nvSpPr>
         <p:spPr>
           <a:xfrm>
-            <a:off x="274320" y="1170432"/>
+            <a:off x="274320" y="1133856"/>
             <a:ext cx="11640312" cy="27432"/>
           </a:xfrm>
           <a:prstGeom prst="rect">
@@ -4727,8 +4730,8 @@
         </p:nvSpPr>
         <p:spPr>
           <a:xfrm>
-            <a:off x="274320" y="1280160"/>
-            <a:ext cx="5669280" cy="5029200"/>
+            <a:off x="274320" y="1234440"/>
+            <a:ext cx="5669280" cy="5120640"/>
           </a:xfrm>
           <a:prstGeom prst="rect">
             <a:avLst/>
@@ -4743,14 +4746,14 @@
           <a:p>
             <a:pPr algn="l"/>
             <a:r>
-              <a:rPr sz="1100" b="0" i="0">
-                <a:solidFill>
-                  <a:srgbClr val="DCE1E6"/>
+              <a:rPr sz="1050" b="0" i="0">
+                <a:solidFill>
+                  <a:srgbClr val="DAE0E6"/>
                 </a:solidFill>
               </a:rPr>
-              <a:t>1. Contractor का original bill upload अनिवार्य। 2. Physical MB का complete PDF।
-3. QC test abstract upload। 4. Bitumen CRC copies upload। 5. Consumption
-Statement और CRC cross-link। 6. Documents absent = payment withheld।</a:t>
+              <a:t>1.Original bill upload। 2.Physical MB PDF। 3.QC abstract। 4.Bitumen CRC
+copies। 5.Consumption Statement cross-link। 6.Centralised CRC Registry।
+7.Documents absent = payment withheld।</a:t>
             </a:r>
           </a:p>
         </p:txBody>
@@ -4763,8 +4766,8 @@
         </p:nvSpPr>
         <p:spPr>
           <a:xfrm>
-            <a:off x="6217920" y="1280160"/>
-            <a:ext cx="5669280" cy="5029200"/>
+            <a:off x="6217920" y="1234440"/>
+            <a:ext cx="5669280" cy="5120640"/>
           </a:xfrm>
           <a:prstGeom prst="rect">
             <a:avLst/>
@@ -4779,15 +4782,16 @@
           <a:p>
             <a:pPr algn="l"/>
             <a:r>
-              <a:rPr sz="1050" b="0" i="1">
-                <a:solidFill>
-                  <a:srgbClr val="AAB9C3"/>
+              <a:rPr sz="1000" b="0" i="1">
+                <a:solidFill>
+                  <a:srgbClr val="A8B9C3"/>
                 </a:solidFill>
               </a:rPr>
-              <a:t>1. Mandate upload of contractor's original bill. 2. Upload complete physical MB
-PDF. 3. Upload QC test abstract. 4. Upload Bitumen CRC copies. 5. Cross-link
-Consumption Statement with CRC (mismatch = auto-flag). 6. Treat missing
-documents as ground for withholding payment.</a:t>
+              <a:t>1.Mandate upload of contractor's original bill. 2.Upload complete physical MB
+PDF. 3.Upload QC test abstract. 4.Upload Bitumen CRC copies. 5.Cross-link
+Consumption Statement with CRC — mismatch auto-flags. 6.Centralised CRC
+Registry — one CRC, one bill only. 7.Missing documents = payment withheld +
+scrutiny initiated.</a:t>
             </a:r>
           </a:p>
         </p:txBody>
@@ -4800,8 +4804,8 @@
         </p:nvSpPr>
         <p:spPr>
           <a:xfrm>
-            <a:off x="6035040" y="1280160"/>
-            <a:ext cx="27432" cy="5029200"/>
+            <a:off x="6035040" y="1234440"/>
+            <a:ext cx="27432" cy="5120640"/>
           </a:xfrm>
           <a:prstGeom prst="rect">
             <a:avLst/>
@@ -4843,8 +4847,8 @@
         </p:nvSpPr>
         <p:spPr>
           <a:xfrm>
-            <a:off x="10972800" y="6492240"/>
-            <a:ext cx="1097280" cy="274320"/>
+            <a:off x="10881360" y="6492240"/>
+            <a:ext cx="1188720" cy="274320"/>
           </a:xfrm>
           <a:prstGeom prst="rect">
             <a:avLst/>
@@ -4861,10 +4865,10 @@
             <a:r>
               <a:rPr sz="800" b="0" i="0">
                 <a:solidFill>
-                  <a:srgbClr val="64788C"/>
+                  <a:srgbClr val="647382"/>
                 </a:solidFill>
               </a:rPr>
-              <a:t>12 / 13</a:t>
+              <a:t>Slide 12 / 13</a:t>
             </a:r>
           </a:p>
         </p:txBody>
@@ -4883,7 +4887,7 @@
     <p:bg>
       <p:bgPr>
         <a:solidFill>
-          <a:srgbClr val="1E3A5F"/>
+          <a:srgbClr val="1A2E50"/>
         </a:solidFill>
         <a:effectLst/>
       </p:bgPr>
@@ -4989,8 +4993,8 @@
         </p:nvSpPr>
         <p:spPr>
           <a:xfrm>
-            <a:off x="274320" y="164592"/>
-            <a:ext cx="1005840" cy="411480"/>
+            <a:off x="274320" y="137160"/>
+            <a:ext cx="1005840" cy="402336"/>
           </a:xfrm>
           <a:prstGeom prst="rect">
             <a:avLst/>
@@ -5032,8 +5036,8 @@
         </p:nvSpPr>
         <p:spPr>
           <a:xfrm>
-            <a:off x="274320" y="164592"/>
-            <a:ext cx="1005840" cy="411480"/>
+            <a:off x="274320" y="137160"/>
+            <a:ext cx="1005840" cy="402336"/>
           </a:xfrm>
           <a:prstGeom prst="rect">
             <a:avLst/>
@@ -5048,7 +5052,7 @@
           <a:p>
             <a:pPr algn="ctr"/>
             <a:r>
-              <a:rPr sz="1100" b="1" i="0">
+              <a:rPr sz="1000" b="1" i="0">
                 <a:solidFill>
                   <a:srgbClr val="FFFFFF"/>
                 </a:solidFill>
@@ -5066,8 +5070,8 @@
         </p:nvSpPr>
         <p:spPr>
           <a:xfrm>
-            <a:off x="1417320" y="137160"/>
-            <a:ext cx="10424160" cy="548640"/>
+            <a:off x="1417320" y="109728"/>
+            <a:ext cx="10424160" cy="530352"/>
           </a:xfrm>
           <a:prstGeom prst="rect">
             <a:avLst/>
@@ -5082,12 +5086,12 @@
           <a:p>
             <a:pPr algn="l"/>
             <a:r>
-              <a:rPr sz="1800" b="1" i="0">
+              <a:rPr sz="1700" b="1" i="0">
                 <a:solidFill>
                   <a:srgbClr val="FFFFFF"/>
                 </a:solidFill>
               </a:rPr>
-              <a:t>मीडिया और जनता से आह्वान — आठ माँगें</a:t>
+              <a:t>तेरह मीडिया और जन माँगें</a:t>
             </a:r>
           </a:p>
         </p:txBody>
@@ -5100,8 +5104,8 @@
         </p:nvSpPr>
         <p:spPr>
           <a:xfrm>
-            <a:off x="1417320" y="658368"/>
-            <a:ext cx="10424160" cy="411480"/>
+            <a:off x="1417320" y="612648"/>
+            <a:ext cx="10424160" cy="402336"/>
           </a:xfrm>
           <a:prstGeom prst="rect">
             <a:avLst/>
@@ -5116,12 +5120,12 @@
           <a:p>
             <a:pPr algn="l"/>
             <a:r>
-              <a:rPr sz="1200" b="1" i="0">
+              <a:rPr sz="1150" b="1" i="0">
                 <a:solidFill>
                   <a:srgbClr val="A0C8DC"/>
                 </a:solidFill>
               </a:rPr>
-              <a:t>Call to Media &amp; Public — Eight Demands</a:t>
+              <a:t>Thirteen Media &amp; Public Demands</a:t>
             </a:r>
           </a:p>
         </p:txBody>
@@ -5134,7 +5138,7 @@
         </p:nvSpPr>
         <p:spPr>
           <a:xfrm>
-            <a:off x="274320" y="1170432"/>
+            <a:off x="274320" y="1133856"/>
             <a:ext cx="11640312" cy="27432"/>
           </a:xfrm>
           <a:prstGeom prst="rect">
@@ -5177,8 +5181,8 @@
         </p:nvSpPr>
         <p:spPr>
           <a:xfrm>
-            <a:off x="274320" y="1280160"/>
-            <a:ext cx="5669280" cy="5029200"/>
+            <a:off x="274320" y="1234440"/>
+            <a:ext cx="5669280" cy="5120640"/>
           </a:xfrm>
           <a:prstGeom prst="rect">
             <a:avLst/>
@@ -5193,15 +5197,15 @@
           <a:p>
             <a:pPr algn="l"/>
             <a:r>
-              <a:rPr sz="1100" b="0" i="0">
-                <a:solidFill>
-                  <a:srgbClr val="DCE1E6"/>
+              <a:rPr sz="1050" b="0" i="0">
+                <a:solidFill>
+                  <a:srgbClr val="DAE0E6"/>
                 </a:solidFill>
               </a:rPr>
-              <a:t>1.RTI — CRC upload status। 2.CAG audit: bitumen claimed vs received। 3.CRC
-verification sting। 4.Recent roads पर core cutting test। 5.Department circular —
-uploads mandatory। 6.Bitumen supplier public list। 7.Public portal — bill
-tracking। 8.ACB investigation — duplicate CRC।</a:t>
+              <a:t>1.RTI CRC upload। 2.CAG bitumen audit। 3.CRC sting। 4.Core cutting test।
+5.Department circular। 6.Supplier public list। 7.Public portal। 8.CRC
+duplication ACB। 9.Dormant deposits RTI। 10.e-EMD expose। 11.Ledger sting।
+12.Recovery RTI। 13.Blacklist register।</a:t>
             </a:r>
           </a:p>
         </p:txBody>
@@ -5214,8 +5218,8 @@
         </p:nvSpPr>
         <p:spPr>
           <a:xfrm>
-            <a:off x="6217920" y="1280160"/>
-            <a:ext cx="5669280" cy="5029200"/>
+            <a:off x="6217920" y="1234440"/>
+            <a:ext cx="5669280" cy="5120640"/>
           </a:xfrm>
           <a:prstGeom prst="rect">
             <a:avLst/>
@@ -5230,15 +5234,17 @@
           <a:p>
             <a:pPr algn="l"/>
             <a:r>
-              <a:rPr sz="1050" b="0" i="1">
-                <a:solidFill>
-                  <a:srgbClr val="AAB9C3"/>
+              <a:rPr sz="1000" b="0" i="1">
+                <a:solidFill>
+                  <a:srgbClr val="A8B9C3"/>
                 </a:solidFill>
               </a:rPr>
-              <a:t>1.RTI on CRC upload status. 2.CAG audit of bitumen claimed vs received. 3.Sting
-on CRC verification. 4.Core cutting test on recent roads. 5.Department circular
-mandating uploads. 6.Public bitumen supplier list. 7.Public portal for bill
-tracking. 8.ACB investigation where CRC is reused.</a:t>
+              <a:t>1.RTI on CRC upload status. 2.CAG audit bitumen claimed vs received. 3.CRC
+verification sting. 4.Core cutting test on recent roads. 5.Department circular
+mandating uploads. 6.Public bitumen supplier list. 7.Public bill tracking
+portal. 8.CRC duplication ACB audit. 9.RTI on dormant EMD/SD deposits.
+10.e-EMD Refund expose. 11.Contractor Ledger sting. 12.Rescinded contracts
+recovery RTI. 13.Blacklisting register demand.</a:t>
             </a:r>
           </a:p>
         </p:txBody>
@@ -5251,8 +5257,8 @@
         </p:nvSpPr>
         <p:spPr>
           <a:xfrm>
-            <a:off x="6035040" y="1280160"/>
-            <a:ext cx="27432" cy="5029200"/>
+            <a:off x="6035040" y="1234440"/>
+            <a:ext cx="27432" cy="5120640"/>
           </a:xfrm>
           <a:prstGeom prst="rect">
             <a:avLst/>
@@ -5294,8 +5300,8 @@
         </p:nvSpPr>
         <p:spPr>
           <a:xfrm>
-            <a:off x="10972800" y="6492240"/>
-            <a:ext cx="1097280" cy="274320"/>
+            <a:off x="10881360" y="6492240"/>
+            <a:ext cx="1188720" cy="274320"/>
           </a:xfrm>
           <a:prstGeom prst="rect">
             <a:avLst/>
@@ -5312,10 +5318,10 @@
             <a:r>
               <a:rPr sz="800" b="0" i="0">
                 <a:solidFill>
-                  <a:srgbClr val="64788C"/>
+                  <a:srgbClr val="647382"/>
                 </a:solidFill>
               </a:rPr>
-              <a:t>13 / 13</a:t>
+              <a:t>Slide 13 / 13</a:t>
             </a:r>
           </a:p>
         </p:txBody>
@@ -5440,8 +5446,8 @@
         </p:nvSpPr>
         <p:spPr>
           <a:xfrm>
-            <a:off x="457200" y="457200"/>
-            <a:ext cx="11274552" cy="731520"/>
+            <a:off x="457200" y="411480"/>
+            <a:ext cx="11274552" cy="685800"/>
           </a:xfrm>
           <a:prstGeom prst="rect">
             <a:avLst/>
@@ -5456,7 +5462,7 @@
           <a:p>
             <a:pPr algn="ctr"/>
             <a:r>
-              <a:rPr sz="2200" b="1" i="0">
+              <a:rPr sz="2100" b="1" i="0">
                 <a:solidFill>
                   <a:srgbClr val="FFFFFF"/>
                 </a:solidFill>
@@ -5474,8 +5480,8 @@
         </p:nvSpPr>
         <p:spPr>
           <a:xfrm>
-            <a:off x="457200" y="1371600"/>
-            <a:ext cx="11274552" cy="914400"/>
+            <a:off x="457200" y="1234440"/>
+            <a:ext cx="11274552" cy="822960"/>
           </a:xfrm>
           <a:prstGeom prst="rect">
             <a:avLst/>
@@ -5490,13 +5496,13 @@
           <a:p>
             <a:pPr algn="ctr"/>
             <a:r>
-              <a:rPr sz="1400" b="0" i="0">
+              <a:rPr sz="1300" b="0" i="0">
                 <a:solidFill>
                   <a:srgbClr val="FFC8C8"/>
                 </a:solidFill>
               </a:rPr>
-              <a:t>RTI FILE करें  •  CAG Audit माँगें  •  ACB को सूचित करें
-File RTI  •  Demand CAG Audit  •  Alert Anti-Corruption Bureau</a:t>
+              <a:t>RTI FILE करें  •  CAG Audit माँगें  •  ACB को सूचित करें  •  Recovery Portal माँगें
+File RTI  •  Demand CAG Audit  •  Alert ACB  •  Demand Recovery Portal</a:t>
             </a:r>
           </a:p>
         </p:txBody>
@@ -5509,8 +5515,8 @@
         </p:nvSpPr>
         <p:spPr>
           <a:xfrm>
-            <a:off x="914400" y="2743200"/>
-            <a:ext cx="10360152" cy="2560320"/>
+            <a:off x="914400" y="2377440"/>
+            <a:ext cx="10360152" cy="3200400"/>
           </a:xfrm>
           <a:prstGeom prst="rect">
             <a:avLst/>
@@ -5525,15 +5531,16 @@
           <a:p>
             <a:pPr algn="ctr"/>
             <a:r>
-              <a:rPr sz="1600" b="0" i="1">
+              <a:rPr sz="1500" b="0" i="1">
                 <a:solidFill>
                   <a:srgbClr val="FFFFFF"/>
                 </a:solidFill>
               </a:rPr>
               <a:t>"जब तक system की monitoring नहीं होगी —
-जनता का पैसा डूबता रहेगा।"
-"Until the system is monitored,
-public money will keep draining."</a:t>
+जनता का पैसा डूबता रहेगा।
+"Recovery Portal बनाना 90 दिन का काम था।
+15 वर्ष में नहीं बना — यह negligence नहीं,
+यह impunity का architecture है।"</a:t>
             </a:r>
           </a:p>
         </p:txBody>
@@ -5547,7 +5554,7 @@
         <p:spPr>
           <a:xfrm>
             <a:off x="457200" y="6217920"/>
-            <a:ext cx="11274552" cy="457200"/>
+            <a:ext cx="11274552" cy="411480"/>
           </a:xfrm>
           <a:prstGeom prst="rect">
             <a:avLst/>
@@ -5649,8 +5656,8 @@
         </p:nvSpPr>
         <p:spPr>
           <a:xfrm>
-            <a:off x="274320" y="137160"/>
-            <a:ext cx="11430000" cy="457200"/>
+            <a:off x="274320" y="109728"/>
+            <a:ext cx="11430000" cy="438912"/>
           </a:xfrm>
           <a:prstGeom prst="rect">
             <a:avLst/>
@@ -5665,7 +5672,7 @@
           <a:p>
             <a:pPr algn="ctr"/>
             <a:r>
-              <a:rPr sz="1400" b="1" i="0">
+              <a:rPr sz="1300" b="1" i="0">
                 <a:solidFill>
                   <a:srgbClr val="0D9488"/>
                 </a:solidFill>
@@ -5683,8 +5690,8 @@
         </p:nvSpPr>
         <p:spPr>
           <a:xfrm>
-            <a:off x="274320" y="777240"/>
-            <a:ext cx="2743200" cy="1234440"/>
+            <a:off x="274320" y="685800"/>
+            <a:ext cx="2743200" cy="1188720"/>
           </a:xfrm>
           <a:prstGeom prst="rect">
             <a:avLst/>
@@ -5728,8 +5735,8 @@
         </p:nvSpPr>
         <p:spPr>
           <a:xfrm>
-            <a:off x="365760" y="868680"/>
-            <a:ext cx="2560320" cy="640080"/>
+            <a:off x="347472" y="758952"/>
+            <a:ext cx="2596896" cy="594360"/>
           </a:xfrm>
           <a:prstGeom prst="rect">
             <a:avLst/>
@@ -5744,7 +5751,7 @@
           <a:p>
             <a:pPr algn="ctr"/>
             <a:r>
-              <a:rPr sz="2200" b="1" i="0">
+              <a:rPr sz="2000" b="1" i="0">
                 <a:solidFill>
                   <a:srgbClr val="FFFFFF"/>
                 </a:solidFill>
@@ -5762,8 +5769,8 @@
         </p:nvSpPr>
         <p:spPr>
           <a:xfrm>
-            <a:off x="365760" y="1463040"/>
-            <a:ext cx="2560320" cy="502920"/>
+            <a:off x="347472" y="1344168"/>
+            <a:ext cx="2596896" cy="475488"/>
           </a:xfrm>
           <a:prstGeom prst="rect">
             <a:avLst/>
@@ -5778,9 +5785,9 @@
           <a:p>
             <a:pPr algn="ctr"/>
             <a:r>
-              <a:rPr sz="850" b="0" i="0">
-                <a:solidFill>
-                  <a:srgbClr val="B4C3D2"/>
+              <a:rPr sz="800" b="0" i="0">
+                <a:solidFill>
+                  <a:srgbClr val="AFBECD"/>
                 </a:solidFill>
               </a:rPr>
               <a:t>e-MB has no line-by-line data — summary only</a:t>
@@ -5796,8 +5803,8 @@
         </p:nvSpPr>
         <p:spPr>
           <a:xfrm>
-            <a:off x="3136391" y="777240"/>
-            <a:ext cx="2743200" cy="1234440"/>
+            <a:off x="3136391" y="685800"/>
+            <a:ext cx="2743200" cy="1188720"/>
           </a:xfrm>
           <a:prstGeom prst="rect">
             <a:avLst/>
@@ -5841,8 +5848,8 @@
         </p:nvSpPr>
         <p:spPr>
           <a:xfrm>
-            <a:off x="3227832" y="868680"/>
-            <a:ext cx="2560320" cy="640080"/>
+            <a:off x="3209544" y="758952"/>
+            <a:ext cx="2596896" cy="594360"/>
           </a:xfrm>
           <a:prstGeom prst="rect">
             <a:avLst/>
@@ -5857,12 +5864,12 @@
           <a:p>
             <a:pPr algn="ctr"/>
             <a:r>
-              <a:rPr sz="2200" b="1" i="0">
+              <a:rPr sz="2000" b="1" i="0">
                 <a:solidFill>
                   <a:srgbClr val="FFFFFF"/>
                 </a:solidFill>
               </a:rPr>
-              <a:t>₹Cr</a:t>
+              <a:t>5</a:t>
             </a:r>
           </a:p>
         </p:txBody>
@@ -5875,8 +5882,8 @@
         </p:nvSpPr>
         <p:spPr>
           <a:xfrm>
-            <a:off x="3227832" y="1463040"/>
-            <a:ext cx="2560320" cy="502920"/>
+            <a:off x="3209544" y="1344168"/>
+            <a:ext cx="2596896" cy="475488"/>
           </a:xfrm>
           <a:prstGeom prst="rect">
             <a:avLst/>
@@ -5891,12 +5898,12 @@
           <a:p>
             <a:pPr algn="ctr"/>
             <a:r>
-              <a:rPr sz="850" b="0" i="0">
-                <a:solidFill>
-                  <a:srgbClr val="B4C3D2"/>
+              <a:rPr sz="800" b="0" i="0">
+                <a:solidFill>
+                  <a:srgbClr val="AFBECD"/>
                 </a:solidFill>
               </a:rPr>
-              <a:t>Bitumen = largest cost component in road projects</a:t>
+              <a:t>CRC Fraud pathways — incl. multi-project reuse</a:t>
             </a:r>
           </a:p>
         </p:txBody>
@@ -5909,8 +5916,8 @@
         </p:nvSpPr>
         <p:spPr>
           <a:xfrm>
-            <a:off x="5998464" y="777240"/>
-            <a:ext cx="2743200" cy="1234440"/>
+            <a:off x="5998464" y="685800"/>
+            <a:ext cx="2743200" cy="1188720"/>
           </a:xfrm>
           <a:prstGeom prst="rect">
             <a:avLst/>
@@ -5954,8 +5961,8 @@
         </p:nvSpPr>
         <p:spPr>
           <a:xfrm>
-            <a:off x="6089903" y="868680"/>
-            <a:ext cx="2560320" cy="640080"/>
+            <a:off x="6071616" y="758952"/>
+            <a:ext cx="2596896" cy="594360"/>
           </a:xfrm>
           <a:prstGeom prst="rect">
             <a:avLst/>
@@ -5970,7 +5977,7 @@
           <a:p>
             <a:pPr algn="ctr"/>
             <a:r>
-              <a:rPr sz="2200" b="1" i="0">
+              <a:rPr sz="2000" b="1" i="0">
                 <a:solidFill>
                   <a:srgbClr val="FFFFFF"/>
                 </a:solidFill>
@@ -5988,8 +5995,8 @@
         </p:nvSpPr>
         <p:spPr>
           <a:xfrm>
-            <a:off x="6089903" y="1463040"/>
-            <a:ext cx="2560320" cy="502920"/>
+            <a:off x="6071616" y="1344168"/>
+            <a:ext cx="2596896" cy="475488"/>
           </a:xfrm>
           <a:prstGeom prst="rect">
             <a:avLst/>
@@ -6004,12 +6011,12 @@
           <a:p>
             <a:pPr algn="ctr"/>
             <a:r>
-              <a:rPr sz="850" b="0" i="0">
-                <a:solidFill>
-                  <a:srgbClr val="B4C3D2"/>
+              <a:rPr sz="800" b="0" i="0">
+                <a:solidFill>
+                  <a:srgbClr val="AFBECD"/>
                 </a:solidFill>
               </a:rPr>
-              <a:t>QC Test Abstracts routinely absent</a:t>
+              <a:t>QC Test Abstracts routinely uploaded</a:t>
             </a:r>
           </a:p>
         </p:txBody>
@@ -6022,8 +6029,8 @@
         </p:nvSpPr>
         <p:spPr>
           <a:xfrm>
-            <a:off x="8860536" y="777240"/>
-            <a:ext cx="2743200" cy="1234440"/>
+            <a:off x="8860536" y="685800"/>
+            <a:ext cx="2743200" cy="1188720"/>
           </a:xfrm>
           <a:prstGeom prst="rect">
             <a:avLst/>
@@ -6067,8 +6074,8 @@
         </p:nvSpPr>
         <p:spPr>
           <a:xfrm>
-            <a:off x="8951976" y="868680"/>
-            <a:ext cx="2560320" cy="640080"/>
+            <a:off x="8933688" y="758952"/>
+            <a:ext cx="2596896" cy="594360"/>
           </a:xfrm>
           <a:prstGeom prst="rect">
             <a:avLst/>
@@ -6083,7 +6090,7 @@
           <a:p>
             <a:pPr algn="ctr"/>
             <a:r>
-              <a:rPr sz="2200" b="1" i="0">
+              <a:rPr sz="2000" b="1" i="0">
                 <a:solidFill>
                   <a:srgbClr val="FFFFFF"/>
                 </a:solidFill>
@@ -6101,8 +6108,8 @@
         </p:nvSpPr>
         <p:spPr>
           <a:xfrm>
-            <a:off x="8951976" y="1463040"/>
-            <a:ext cx="2560320" cy="502920"/>
+            <a:off x="8933688" y="1344168"/>
+            <a:ext cx="2596896" cy="475488"/>
           </a:xfrm>
           <a:prstGeom prst="rect">
             <a:avLst/>
@@ -6117,12 +6124,12 @@
           <a:p>
             <a:pPr algn="ctr"/>
             <a:r>
-              <a:rPr sz="850" b="0" i="0">
-                <a:solidFill>
-                  <a:srgbClr val="B4C3D2"/>
+              <a:rPr sz="800" b="0" i="0">
+                <a:solidFill>
+                  <a:srgbClr val="AFBECD"/>
                 </a:solidFill>
               </a:rPr>
-              <a:t>Bitumen CRC — 'Single Mother of Corruption' in PWD</a:t>
+              <a:t>Bitumen CRC — Single Mother of Corruption</a:t>
             </a:r>
           </a:p>
         </p:txBody>
@@ -6135,8 +6142,8 @@
         </p:nvSpPr>
         <p:spPr>
           <a:xfrm>
-            <a:off x="274320" y="2176272"/>
-            <a:ext cx="2743200" cy="1234440"/>
+            <a:off x="274320" y="2020824"/>
+            <a:ext cx="2743200" cy="1188720"/>
           </a:xfrm>
           <a:prstGeom prst="rect">
             <a:avLst/>
@@ -6180,8 +6187,8 @@
         </p:nvSpPr>
         <p:spPr>
           <a:xfrm>
-            <a:off x="365760" y="2267712"/>
-            <a:ext cx="2560320" cy="640080"/>
+            <a:off x="347472" y="2093976"/>
+            <a:ext cx="2596896" cy="594360"/>
           </a:xfrm>
           <a:prstGeom prst="rect">
             <a:avLst/>
@@ -6196,12 +6203,12 @@
           <a:p>
             <a:pPr algn="ctr"/>
             <a:r>
-              <a:rPr sz="2200" b="1" i="0">
+              <a:rPr sz="2000" b="1" i="0">
                 <a:solidFill>
                   <a:srgbClr val="FFFFFF"/>
                 </a:solidFill>
               </a:rPr>
-              <a:t>5</a:t>
+              <a:t>15 Yrs</a:t>
             </a:r>
           </a:p>
         </p:txBody>
@@ -6214,8 +6221,8 @@
         </p:nvSpPr>
         <p:spPr>
           <a:xfrm>
-            <a:off x="365760" y="2862072"/>
-            <a:ext cx="2560320" cy="502920"/>
+            <a:off x="347472" y="2679191"/>
+            <a:ext cx="2596896" cy="475488"/>
           </a:xfrm>
           <a:prstGeom prst="rect">
             <a:avLst/>
@@ -6230,12 +6237,12 @@
           <a:p>
             <a:pPr algn="ctr"/>
             <a:r>
-              <a:rPr sz="850" b="0" i="0">
-                <a:solidFill>
-                  <a:srgbClr val="B4C3D2"/>
+              <a:rPr sz="800" b="0" i="0">
+                <a:solidFill>
+                  <a:srgbClr val="AFBECD"/>
                 </a:solidFill>
               </a:rPr>
-              <a:t>CRC Fraud pathways — incl. multi-project reuse</a:t>
+              <a:t>Online payments — ZERO Contractor Ledger built</a:t>
             </a:r>
           </a:p>
         </p:txBody>
@@ -6248,8 +6255,8 @@
         </p:nvSpPr>
         <p:spPr>
           <a:xfrm>
-            <a:off x="3136391" y="2176272"/>
-            <a:ext cx="2743200" cy="1234440"/>
+            <a:off x="3136391" y="2020824"/>
+            <a:ext cx="2743200" cy="1188720"/>
           </a:xfrm>
           <a:prstGeom prst="rect">
             <a:avLst/>
@@ -6293,8 +6300,8 @@
         </p:nvSpPr>
         <p:spPr>
           <a:xfrm>
-            <a:off x="3227832" y="2267712"/>
-            <a:ext cx="2560320" cy="640080"/>
+            <a:off x="3209544" y="2093976"/>
+            <a:ext cx="2596896" cy="594360"/>
           </a:xfrm>
           <a:prstGeom prst="rect">
             <a:avLst/>
@@ -6309,12 +6316,12 @@
           <a:p>
             <a:pPr algn="ctr"/>
             <a:r>
-              <a:rPr sz="2200" b="1" i="0">
+              <a:rPr sz="2000" b="1" i="0">
                 <a:solidFill>
                   <a:srgbClr val="FFFFFF"/>
                 </a:solidFill>
               </a:rPr>
-              <a:t>Nil</a:t>
+              <a:t>EMD+SD</a:t>
             </a:r>
           </a:p>
         </p:txBody>
@@ -6327,8 +6334,8 @@
         </p:nvSpPr>
         <p:spPr>
           <a:xfrm>
-            <a:off x="3227832" y="2862072"/>
-            <a:ext cx="2560320" cy="502920"/>
+            <a:off x="3209544" y="2679191"/>
+            <a:ext cx="2596896" cy="475488"/>
           </a:xfrm>
           <a:prstGeom prst="rect">
             <a:avLst/>
@@ -6343,12 +6350,12 @@
           <a:p>
             <a:pPr algn="ctr"/>
             <a:r>
-              <a:rPr sz="850" b="0" i="0">
-                <a:solidFill>
-                  <a:srgbClr val="B4C3D2"/>
+              <a:rPr sz="800" b="0" i="0">
+                <a:solidFill>
+                  <a:srgbClr val="AFBECD"/>
                 </a:solidFill>
               </a:rPr>
-              <a:t>Consumption Statement links in digital billing</a:t>
+              <a:t>Dormant deposits — no ledger, no statement, no refund</a:t>
             </a:r>
           </a:p>
         </p:txBody>
@@ -6361,8 +6368,8 @@
         </p:nvSpPr>
         <p:spPr>
           <a:xfrm>
-            <a:off x="5998464" y="2176272"/>
-            <a:ext cx="2743200" cy="1234440"/>
+            <a:off x="5998464" y="2020824"/>
+            <a:ext cx="2743200" cy="1188720"/>
           </a:xfrm>
           <a:prstGeom prst="rect">
             <a:avLst/>
@@ -6406,8 +6413,8 @@
         </p:nvSpPr>
         <p:spPr>
           <a:xfrm>
-            <a:off x="6089903" y="2267712"/>
-            <a:ext cx="2560320" cy="640080"/>
+            <a:off x="6071616" y="2093976"/>
+            <a:ext cx="2596896" cy="594360"/>
           </a:xfrm>
           <a:prstGeom prst="rect">
             <a:avLst/>
@@ -6422,12 +6429,12 @@
           <a:p>
             <a:pPr algn="ctr"/>
             <a:r>
-              <a:rPr sz="2200" b="1" i="0">
+              <a:rPr sz="2000" b="1" i="0">
                 <a:solidFill>
                   <a:srgbClr val="FFFFFF"/>
                 </a:solidFill>
               </a:rPr>
-              <a:t>Early</a:t>
+              <a:t>~200</a:t>
             </a:r>
           </a:p>
         </p:txBody>
@@ -6440,8 +6447,8 @@
         </p:nvSpPr>
         <p:spPr>
           <a:xfrm>
-            <a:off x="6089903" y="2862072"/>
-            <a:ext cx="2560320" cy="502920"/>
+            <a:off x="6071616" y="2679191"/>
+            <a:ext cx="2596896" cy="475488"/>
           </a:xfrm>
           <a:prstGeom prst="rect">
             <a:avLst/>
@@ -6456,12 +6463,12 @@
           <a:p>
             <a:pPr algn="ctr"/>
             <a:r>
-              <a:rPr sz="850" b="0" i="0">
-                <a:solidFill>
-                  <a:srgbClr val="B4C3D2"/>
+              <a:rPr sz="800" b="0" i="0">
+                <a:solidFill>
+                  <a:srgbClr val="AFBECD"/>
                 </a:solidFill>
               </a:rPr>
-              <a:t>Road failures due to sub-standard bitumen</a:t>
+              <a:t>Contracts rescinded — ZERO recovery monitoring</a:t>
             </a:r>
           </a:p>
         </p:txBody>
@@ -6474,8 +6481,8 @@
         </p:nvSpPr>
         <p:spPr>
           <a:xfrm>
-            <a:off x="8860536" y="2176272"/>
-            <a:ext cx="2743200" cy="1234440"/>
+            <a:off x="8860536" y="2020824"/>
+            <a:ext cx="2743200" cy="1188720"/>
           </a:xfrm>
           <a:prstGeom prst="rect">
             <a:avLst/>
@@ -6519,8 +6526,8 @@
         </p:nvSpPr>
         <p:spPr>
           <a:xfrm>
-            <a:off x="8951976" y="2267712"/>
-            <a:ext cx="2560320" cy="640080"/>
+            <a:off x="8933688" y="2093976"/>
+            <a:ext cx="2596896" cy="594360"/>
           </a:xfrm>
           <a:prstGeom prst="rect">
             <a:avLst/>
@@ -6535,12 +6542,12 @@
           <a:p>
             <a:pPr algn="ctr"/>
             <a:r>
-              <a:rPr sz="2200" b="1" i="0">
+              <a:rPr sz="2000" b="1" i="0">
                 <a:solidFill>
                   <a:srgbClr val="FFFFFF"/>
                 </a:solidFill>
               </a:rPr>
-              <a:t>Unaudited</a:t>
+              <a:t>90 Days</a:t>
             </a:r>
           </a:p>
         </p:txBody>
@@ -6553,8 +6560,8 @@
         </p:nvSpPr>
         <p:spPr>
           <a:xfrm>
-            <a:off x="8951976" y="2862072"/>
-            <a:ext cx="2560320" cy="502920"/>
+            <a:off x="8933688" y="2679191"/>
+            <a:ext cx="2596896" cy="475488"/>
           </a:xfrm>
           <a:prstGeom prst="rect">
             <a:avLst/>
@@ -6569,12 +6576,12 @@
           <a:p>
             <a:pPr algn="ctr"/>
             <a:r>
-              <a:rPr sz="850" b="0" i="0">
-                <a:solidFill>
-                  <a:srgbClr val="B4C3D2"/>
+              <a:rPr sz="800" b="0" i="0">
+                <a:solidFill>
+                  <a:srgbClr val="AFBECD"/>
                 </a:solidFill>
               </a:rPr>
-              <a:t>e-MB Abstract = unverifiable financial claim</a:t>
+              <a:t>Time to build Recovery Portal — never done</a:t>
             </a:r>
           </a:p>
         </p:txBody>
@@ -6699,8 +6706,8 @@
         </p:nvSpPr>
         <p:spPr>
           <a:xfrm>
-            <a:off x="274320" y="164592"/>
-            <a:ext cx="1005840" cy="411480"/>
+            <a:off x="274320" y="137160"/>
+            <a:ext cx="1005840" cy="402336"/>
           </a:xfrm>
           <a:prstGeom prst="rect">
             <a:avLst/>
@@ -6742,8 +6749,8 @@
         </p:nvSpPr>
         <p:spPr>
           <a:xfrm>
-            <a:off x="274320" y="164592"/>
-            <a:ext cx="1005840" cy="411480"/>
+            <a:off x="274320" y="137160"/>
+            <a:ext cx="1005840" cy="402336"/>
           </a:xfrm>
           <a:prstGeom prst="rect">
             <a:avLst/>
@@ -6758,7 +6765,7 @@
           <a:p>
             <a:pPr algn="ctr"/>
             <a:r>
-              <a:rPr sz="1100" b="1" i="0">
+              <a:rPr sz="1000" b="1" i="0">
                 <a:solidFill>
                   <a:srgbClr val="FFFFFF"/>
                 </a:solidFill>
@@ -6776,8 +6783,8 @@
         </p:nvSpPr>
         <p:spPr>
           <a:xfrm>
-            <a:off x="1417320" y="137160"/>
-            <a:ext cx="10424160" cy="548640"/>
+            <a:off x="1417320" y="109728"/>
+            <a:ext cx="10424160" cy="530352"/>
           </a:xfrm>
           <a:prstGeom prst="rect">
             <a:avLst/>
@@ -6792,7 +6799,7 @@
           <a:p>
             <a:pPr algn="l"/>
             <a:r>
-              <a:rPr sz="1800" b="1" i="0">
+              <a:rPr sz="1700" b="1" i="0">
                 <a:solidFill>
                   <a:srgbClr val="FFFFFF"/>
                 </a:solidFill>
@@ -6810,8 +6817,8 @@
         </p:nvSpPr>
         <p:spPr>
           <a:xfrm>
-            <a:off x="1417320" y="658368"/>
-            <a:ext cx="10424160" cy="411480"/>
+            <a:off x="1417320" y="612648"/>
+            <a:ext cx="10424160" cy="402336"/>
           </a:xfrm>
           <a:prstGeom prst="rect">
             <a:avLst/>
@@ -6826,7 +6833,7 @@
           <a:p>
             <a:pPr algn="l"/>
             <a:r>
-              <a:rPr sz="1200" b="1" i="0">
+              <a:rPr sz="1150" b="1" i="0">
                 <a:solidFill>
                   <a:srgbClr val="A0C8DC"/>
                 </a:solidFill>
@@ -6844,7 +6851,7 @@
         </p:nvSpPr>
         <p:spPr>
           <a:xfrm>
-            <a:off x="274320" y="1170432"/>
+            <a:off x="274320" y="1133856"/>
             <a:ext cx="11640312" cy="27432"/>
           </a:xfrm>
           <a:prstGeom prst="rect">
@@ -6887,8 +6894,8 @@
         </p:nvSpPr>
         <p:spPr>
           <a:xfrm>
-            <a:off x="274320" y="1280160"/>
-            <a:ext cx="5669280" cy="5029200"/>
+            <a:off x="274320" y="1234440"/>
+            <a:ext cx="5669280" cy="5120640"/>
           </a:xfrm>
           <a:prstGeom prst="rect">
             <a:avLst/>
@@ -6903,14 +6910,13 @@
           <a:p>
             <a:pPr algn="l"/>
             <a:r>
-              <a:rPr sz="1100" b="0" i="0">
-                <a:solidFill>
-                  <a:srgbClr val="DCE1E6"/>
+              <a:rPr sz="1050" b="0" i="0">
+                <a:solidFill>
+                  <a:srgbClr val="DAE0E6"/>
                 </a:solidFill>
               </a:rPr>
-              <a:t>Electronic Measurement Book पारदर्शिता, सटीकता और जवाबदेही लाने के लिए था। इसकी
-जगह यह एक sanitised abstract तैयार करता है जो over-measurement, quality
-shortfalls और Bitumen हेराफेरी छुपाता है।</a:t>
+              <a:t>eMB पारदर्शिता लाने के लिए था। इसकी जगह यह एक sanitised abstract तैयार करता है
+जो fraud छुपाता है।</a:t>
             </a:r>
           </a:p>
         </p:txBody>
@@ -6923,8 +6929,8 @@
         </p:nvSpPr>
         <p:spPr>
           <a:xfrm>
-            <a:off x="6217920" y="1280160"/>
-            <a:ext cx="5669280" cy="5029200"/>
+            <a:off x="6217920" y="1234440"/>
+            <a:ext cx="5669280" cy="5120640"/>
           </a:xfrm>
           <a:prstGeom prst="rect">
             <a:avLst/>
@@ -6939,15 +6945,15 @@
           <a:p>
             <a:pPr algn="l"/>
             <a:r>
-              <a:rPr sz="1050" b="0" i="1">
-                <a:solidFill>
-                  <a:srgbClr val="AAB9C3"/>
+              <a:rPr sz="1000" b="0" i="1">
+                <a:solidFill>
+                  <a:srgbClr val="A8B9C3"/>
                 </a:solidFill>
               </a:rPr>
-              <a:t>The Electronic Measurement Book was designed to bring transparency, accuracy and
-accountability to civil works billing. Instead it produces a sanitised abstract
-that conceals the very details needed to detect over-measurement, quality
-shortfalls and bitumen record manipulation.</a:t>
+              <a:t>The Electronic Measurement Book was designed to bring transparency, accuracy
+and accountability. Instead it produces a sanitised abstract that conceals
+exactly what is needed to detect over-measurement, quality shortfalls, and
+bitumen manipulation.</a:t>
             </a:r>
           </a:p>
         </p:txBody>
@@ -6960,8 +6966,8 @@
         </p:nvSpPr>
         <p:spPr>
           <a:xfrm>
-            <a:off x="6035040" y="1280160"/>
-            <a:ext cx="27432" cy="5029200"/>
+            <a:off x="6035040" y="1234440"/>
+            <a:ext cx="27432" cy="5120640"/>
           </a:xfrm>
           <a:prstGeom prst="rect">
             <a:avLst/>
@@ -7003,8 +7009,8 @@
         </p:nvSpPr>
         <p:spPr>
           <a:xfrm>
-            <a:off x="10972800" y="6492240"/>
-            <a:ext cx="1097280" cy="274320"/>
+            <a:off x="10881360" y="6492240"/>
+            <a:ext cx="1188720" cy="274320"/>
           </a:xfrm>
           <a:prstGeom prst="rect">
             <a:avLst/>
@@ -7021,10 +7027,10 @@
             <a:r>
               <a:rPr sz="800" b="0" i="0">
                 <a:solidFill>
-                  <a:srgbClr val="64788C"/>
+                  <a:srgbClr val="647382"/>
                 </a:solidFill>
               </a:rPr>
-              <a:t>3 / 13</a:t>
+              <a:t>Slide 3 / 13</a:t>
             </a:r>
           </a:p>
         </p:txBody>
@@ -7149,8 +7155,8 @@
         </p:nvSpPr>
         <p:spPr>
           <a:xfrm>
-            <a:off x="274320" y="164592"/>
-            <a:ext cx="1005840" cy="411480"/>
+            <a:off x="274320" y="137160"/>
+            <a:ext cx="1005840" cy="402336"/>
           </a:xfrm>
           <a:prstGeom prst="rect">
             <a:avLst/>
@@ -7192,8 +7198,8 @@
         </p:nvSpPr>
         <p:spPr>
           <a:xfrm>
-            <a:off x="274320" y="164592"/>
-            <a:ext cx="1005840" cy="411480"/>
+            <a:off x="274320" y="137160"/>
+            <a:ext cx="1005840" cy="402336"/>
           </a:xfrm>
           <a:prstGeom prst="rect">
             <a:avLst/>
@@ -7208,7 +7214,7 @@
           <a:p>
             <a:pPr algn="ctr"/>
             <a:r>
-              <a:rPr sz="1100" b="1" i="0">
+              <a:rPr sz="1000" b="1" i="0">
                 <a:solidFill>
                   <a:srgbClr val="FFFFFF"/>
                 </a:solidFill>
@@ -7226,8 +7232,8 @@
         </p:nvSpPr>
         <p:spPr>
           <a:xfrm>
-            <a:off x="1417320" y="137160"/>
-            <a:ext cx="10424160" cy="548640"/>
+            <a:off x="1417320" y="109728"/>
+            <a:ext cx="10424160" cy="530352"/>
           </a:xfrm>
           <a:prstGeom prst="rect">
             <a:avLst/>
@@ -7242,7 +7248,7 @@
           <a:p>
             <a:pPr algn="l"/>
             <a:r>
-              <a:rPr sz="1800" b="1" i="0">
+              <a:rPr sz="1700" b="1" i="0">
                 <a:solidFill>
                   <a:srgbClr val="FFFFFF"/>
                 </a:solidFill>
@@ -7260,8 +7266,8 @@
         </p:nvSpPr>
         <p:spPr>
           <a:xfrm>
-            <a:off x="1417320" y="658368"/>
-            <a:ext cx="10424160" cy="411480"/>
+            <a:off x="1417320" y="612648"/>
+            <a:ext cx="10424160" cy="402336"/>
           </a:xfrm>
           <a:prstGeom prst="rect">
             <a:avLst/>
@@ -7276,7 +7282,7 @@
           <a:p>
             <a:pPr algn="l"/>
             <a:r>
-              <a:rPr sz="1200" b="1" i="0">
+              <a:rPr sz="1150" b="1" i="0">
                 <a:solidFill>
                   <a:srgbClr val="A0C8DC"/>
                 </a:solidFill>
@@ -7294,7 +7300,7 @@
         </p:nvSpPr>
         <p:spPr>
           <a:xfrm>
-            <a:off x="274320" y="1170432"/>
+            <a:off x="274320" y="1133856"/>
             <a:ext cx="11640312" cy="27432"/>
           </a:xfrm>
           <a:prstGeom prst="rect">
@@ -7337,8 +7343,8 @@
         </p:nvSpPr>
         <p:spPr>
           <a:xfrm>
-            <a:off x="274320" y="1280160"/>
-            <a:ext cx="5669280" cy="5029200"/>
+            <a:off x="274320" y="1234440"/>
+            <a:ext cx="5669280" cy="5120640"/>
           </a:xfrm>
           <a:prstGeom prst="rect">
             <a:avLst/>
@@ -7353,14 +7359,14 @@
           <a:p>
             <a:pPr algn="l"/>
             <a:r>
-              <a:rPr sz="1100" b="0" i="0">
-                <a:solidFill>
-                  <a:srgbClr val="DCE1E6"/>
+              <a:rPr sz="1050" b="0" i="0">
+                <a:solidFill>
+                  <a:srgbClr val="DAE0E6"/>
                 </a:solidFill>
               </a:rPr>
-              <a:t>eMB में missing: Chainage-wise quantities, Layer-wise thickness, Cross-sections,
-Progressive totals। दो अनिवार्य actions: (1) Contractor का original bill full
-upload। (2) Physical MB का complete PDF।</a:t>
+              <a:t>eMB में missing: Chainage-wise quantities, Layer-wise thickness, Cross-
+sections, Progressive totals। दो अनिवार्य actions: Original bill upload +
+Physical MB PDF।</a:t>
             </a:r>
           </a:p>
         </p:txBody>
@@ -7373,8 +7379,8 @@
         </p:nvSpPr>
         <p:spPr>
           <a:xfrm>
-            <a:off x="6217920" y="1280160"/>
-            <a:ext cx="5669280" cy="5029200"/>
+            <a:off x="6217920" y="1234440"/>
+            <a:ext cx="5669280" cy="5120640"/>
           </a:xfrm>
           <a:prstGeom prst="rect">
             <a:avLst/>
@@ -7389,16 +7395,15 @@
           <a:p>
             <a:pPr algn="l"/>
             <a:r>
-              <a:rPr sz="1050" b="0" i="1">
-                <a:solidFill>
-                  <a:srgbClr val="AAB9C3"/>
+              <a:rPr sz="1000" b="0" i="1">
+                <a:solidFill>
+                  <a:srgbClr val="A8B9C3"/>
                 </a:solidFill>
               </a:rPr>
               <a:t>Missing from e-MB: chainage-wise quantities, layer-wise thicknesses, cross-
-sectional measurements, progressive totals. Two non-negotiable mandatory actions
-when full digital entry is impractical: (1) Upload contractor's original bill in
-full. (2) Upload clear PDF of physical MB with complete line-by-line
-measurements.</a:t>
+sectional measurements, progressive totals. Two non-negotiable actions when
+full digital entry is impractical: (1) Upload contractor's original bill in
+full. (2) Upload complete physical MB as PDF.</a:t>
             </a:r>
           </a:p>
         </p:txBody>
@@ -7411,8 +7416,8 @@
         </p:nvSpPr>
         <p:spPr>
           <a:xfrm>
-            <a:off x="6035040" y="1280160"/>
-            <a:ext cx="27432" cy="5029200"/>
+            <a:off x="6035040" y="1234440"/>
+            <a:ext cx="27432" cy="5120640"/>
           </a:xfrm>
           <a:prstGeom prst="rect">
             <a:avLst/>
@@ -7454,8 +7459,8 @@
         </p:nvSpPr>
         <p:spPr>
           <a:xfrm>
-            <a:off x="10972800" y="6492240"/>
-            <a:ext cx="1097280" cy="274320"/>
+            <a:off x="10881360" y="6492240"/>
+            <a:ext cx="1188720" cy="274320"/>
           </a:xfrm>
           <a:prstGeom prst="rect">
             <a:avLst/>
@@ -7472,10 +7477,10 @@
             <a:r>
               <a:rPr sz="800" b="0" i="0">
                 <a:solidFill>
-                  <a:srgbClr val="64788C"/>
+                  <a:srgbClr val="647382"/>
                 </a:solidFill>
               </a:rPr>
-              <a:t>4 / 13</a:t>
+              <a:t>Slide 4 / 13</a:t>
             </a:r>
           </a:p>
         </p:txBody>
@@ -7600,8 +7605,8 @@
         </p:nvSpPr>
         <p:spPr>
           <a:xfrm>
-            <a:off x="274320" y="164592"/>
-            <a:ext cx="1005840" cy="411480"/>
+            <a:off x="274320" y="137160"/>
+            <a:ext cx="1005840" cy="402336"/>
           </a:xfrm>
           <a:prstGeom prst="rect">
             <a:avLst/>
@@ -7643,8 +7648,8 @@
         </p:nvSpPr>
         <p:spPr>
           <a:xfrm>
-            <a:off x="274320" y="164592"/>
-            <a:ext cx="1005840" cy="411480"/>
+            <a:off x="274320" y="137160"/>
+            <a:ext cx="1005840" cy="402336"/>
           </a:xfrm>
           <a:prstGeom prst="rect">
             <a:avLst/>
@@ -7659,7 +7664,7 @@
           <a:p>
             <a:pPr algn="ctr"/>
             <a:r>
-              <a:rPr sz="1100" b="1" i="0">
+              <a:rPr sz="1000" b="1" i="0">
                 <a:solidFill>
                   <a:srgbClr val="FFFFFF"/>
                 </a:solidFill>
@@ -7677,8 +7682,8 @@
         </p:nvSpPr>
         <p:spPr>
           <a:xfrm>
-            <a:off x="1417320" y="137160"/>
-            <a:ext cx="10424160" cy="548640"/>
+            <a:off x="1417320" y="109728"/>
+            <a:ext cx="10424160" cy="530352"/>
           </a:xfrm>
           <a:prstGeom prst="rect">
             <a:avLst/>
@@ -7693,12 +7698,12 @@
           <a:p>
             <a:pPr algn="l"/>
             <a:r>
-              <a:rPr sz="1800" b="1" i="0">
+              <a:rPr sz="1700" b="1" i="0">
                 <a:solidFill>
                   <a:srgbClr val="FFFFFF"/>
                 </a:solidFill>
               </a:rPr>
-              <a:t>Missing QC Records — गुणवत्ता कागज़ पर</a:t>
+              <a:t>Missing QC Records — गुणवत्ता कागज़ पर, ज़मीन पर नहीं</a:t>
             </a:r>
           </a:p>
         </p:txBody>
@@ -7711,8 +7716,8 @@
         </p:nvSpPr>
         <p:spPr>
           <a:xfrm>
-            <a:off x="1417320" y="658368"/>
-            <a:ext cx="10424160" cy="411480"/>
+            <a:off x="1417320" y="612648"/>
+            <a:ext cx="10424160" cy="402336"/>
           </a:xfrm>
           <a:prstGeom prst="rect">
             <a:avLst/>
@@ -7727,7 +7732,7 @@
           <a:p>
             <a:pPr algn="l"/>
             <a:r>
-              <a:rPr sz="1200" b="1" i="0">
+              <a:rPr sz="1150" b="1" i="0">
                 <a:solidFill>
                   <a:srgbClr val="A0C8DC"/>
                 </a:solidFill>
@@ -7745,7 +7750,7 @@
         </p:nvSpPr>
         <p:spPr>
           <a:xfrm>
-            <a:off x="274320" y="1170432"/>
+            <a:off x="274320" y="1133856"/>
             <a:ext cx="11640312" cy="27432"/>
           </a:xfrm>
           <a:prstGeom prst="rect">
@@ -7788,8 +7793,8 @@
         </p:nvSpPr>
         <p:spPr>
           <a:xfrm>
-            <a:off x="274320" y="1280160"/>
-            <a:ext cx="5669280" cy="5029200"/>
+            <a:off x="274320" y="1234440"/>
+            <a:ext cx="5669280" cy="5120640"/>
           </a:xfrm>
           <a:prstGeom prst="rect">
             <a:avLst/>
@@ -7804,14 +7809,13 @@
           <a:p>
             <a:pPr algn="l"/>
             <a:r>
-              <a:rPr sz="1100" b="0" i="0">
-                <a:solidFill>
-                  <a:srgbClr val="DCE1E6"/>
+              <a:rPr sz="1050" b="0" i="0">
+                <a:solidFill>
+                  <a:srgbClr val="DAE0E6"/>
                 </a:solidFill>
               </a:rPr>
-              <a:t>Grade, density, Marshall stability, binder content — laboratory test results eMB
-billing trail में routinely absent। Materials ने specified standards पूरे किए या
-नहीं — कोई accessible record नहीं।</a:t>
+              <a:t>Grade, density, Marshall stability, binder content — test results absent।
+Quality केवल कागज़ पर।</a:t>
             </a:r>
           </a:p>
         </p:txBody>
@@ -7824,8 +7828,8 @@
         </p:nvSpPr>
         <p:spPr>
           <a:xfrm>
-            <a:off x="6217920" y="1280160"/>
-            <a:ext cx="5669280" cy="5029200"/>
+            <a:off x="6217920" y="1234440"/>
+            <a:ext cx="5669280" cy="5120640"/>
           </a:xfrm>
           <a:prstGeom prst="rect">
             <a:avLst/>
@@ -7840,15 +7844,14 @@
           <a:p>
             <a:pPr algn="l"/>
             <a:r>
-              <a:rPr sz="1050" b="0" i="1">
-                <a:solidFill>
-                  <a:srgbClr val="AAB9C3"/>
+              <a:rPr sz="1000" b="0" i="1">
+                <a:solidFill>
+                  <a:srgbClr val="A8B9C3"/>
                 </a:solidFill>
               </a:rPr>
-              <a:t>Laboratory test results for bitumen grade, density, Marshall stability and
-binder content are routinely absent from e-MB billing trails. No accessible
-record exists of whether materials met specified standards. Quality Control
-exists only on paper.</a:t>
+              <a:t>Laboratory test results for bitumen grade, density, Marshall stability, and
+binder content are routinely absent. No accessible record of whether materials
+met specified standards. QC exists only on paper.</a:t>
             </a:r>
           </a:p>
         </p:txBody>
@@ -7861,8 +7864,8 @@
         </p:nvSpPr>
         <p:spPr>
           <a:xfrm>
-            <a:off x="6035040" y="1280160"/>
-            <a:ext cx="27432" cy="5029200"/>
+            <a:off x="6035040" y="1234440"/>
+            <a:ext cx="27432" cy="5120640"/>
           </a:xfrm>
           <a:prstGeom prst="rect">
             <a:avLst/>
@@ -7904,8 +7907,8 @@
         </p:nvSpPr>
         <p:spPr>
           <a:xfrm>
-            <a:off x="10972800" y="6492240"/>
-            <a:ext cx="1097280" cy="274320"/>
+            <a:off x="10881360" y="6492240"/>
+            <a:ext cx="1188720" cy="274320"/>
           </a:xfrm>
           <a:prstGeom prst="rect">
             <a:avLst/>
@@ -7922,10 +7925,10 @@
             <a:r>
               <a:rPr sz="800" b="0" i="0">
                 <a:solidFill>
-                  <a:srgbClr val="64788C"/>
+                  <a:srgbClr val="647382"/>
                 </a:solidFill>
               </a:rPr>
-              <a:t>5 / 13</a:t>
+              <a:t>Slide 5 / 13</a:t>
             </a:r>
           </a:p>
         </p:txBody>
@@ -8050,8 +8053,8 @@
         </p:nvSpPr>
         <p:spPr>
           <a:xfrm>
-            <a:off x="274320" y="164592"/>
-            <a:ext cx="1005840" cy="411480"/>
+            <a:off x="274320" y="137160"/>
+            <a:ext cx="1005840" cy="402336"/>
           </a:xfrm>
           <a:prstGeom prst="rect">
             <a:avLst/>
@@ -8093,8 +8096,8 @@
         </p:nvSpPr>
         <p:spPr>
           <a:xfrm>
-            <a:off x="274320" y="164592"/>
-            <a:ext cx="1005840" cy="411480"/>
+            <a:off x="274320" y="137160"/>
+            <a:ext cx="1005840" cy="402336"/>
           </a:xfrm>
           <a:prstGeom prst="rect">
             <a:avLst/>
@@ -8109,7 +8112,7 @@
           <a:p>
             <a:pPr algn="ctr"/>
             <a:r>
-              <a:rPr sz="1100" b="1" i="0">
+              <a:rPr sz="1000" b="1" i="0">
                 <a:solidFill>
                   <a:srgbClr val="FFFFFF"/>
                 </a:solidFill>
@@ -8127,8 +8130,8 @@
         </p:nvSpPr>
         <p:spPr>
           <a:xfrm>
-            <a:off x="1417320" y="137160"/>
-            <a:ext cx="10424160" cy="548640"/>
+            <a:off x="1417320" y="109728"/>
+            <a:ext cx="10424160" cy="530352"/>
           </a:xfrm>
           <a:prstGeom prst="rect">
             <a:avLst/>
@@ -8143,7 +8146,7 @@
           <a:p>
             <a:pPr algn="l"/>
             <a:r>
-              <a:rPr sz="1800" b="1" i="0">
+              <a:rPr sz="1700" b="1" i="0">
                 <a:solidFill>
                   <a:srgbClr val="FFFFFF"/>
                 </a:solidFill>
@@ -8161,8 +8164,8 @@
         </p:nvSpPr>
         <p:spPr>
           <a:xfrm>
-            <a:off x="1417320" y="658368"/>
-            <a:ext cx="10424160" cy="411480"/>
+            <a:off x="1417320" y="612648"/>
+            <a:ext cx="10424160" cy="402336"/>
           </a:xfrm>
           <a:prstGeom prst="rect">
             <a:avLst/>
@@ -8177,7 +8180,7 @@
           <a:p>
             <a:pPr algn="l"/>
             <a:r>
-              <a:rPr sz="1200" b="1" i="0">
+              <a:rPr sz="1150" b="1" i="0">
                 <a:solidFill>
                   <a:srgbClr val="A0C8DC"/>
                 </a:solidFill>
@@ -8195,7 +8198,7 @@
         </p:nvSpPr>
         <p:spPr>
           <a:xfrm>
-            <a:off x="274320" y="1170432"/>
+            <a:off x="274320" y="1133856"/>
             <a:ext cx="11640312" cy="27432"/>
           </a:xfrm>
           <a:prstGeom prst="rect">
@@ -8238,8 +8241,8 @@
         </p:nvSpPr>
         <p:spPr>
           <a:xfrm>
-            <a:off x="274320" y="1280160"/>
-            <a:ext cx="5669280" cy="5029200"/>
+            <a:off x="274320" y="1234440"/>
+            <a:ext cx="5669280" cy="5120640"/>
           </a:xfrm>
           <a:prstGeom prst="rect">
             <a:avLst/>
@@ -8254,15 +8257,13 @@
           <a:p>
             <a:pPr algn="l"/>
             <a:r>
-              <a:rPr sz="1100" b="0" i="0">
-                <a:solidFill>
-                  <a:srgbClr val="DCE1E6"/>
+              <a:rPr sz="1050" b="0" i="0">
+                <a:solidFill>
+                  <a:srgbClr val="DAE0E6"/>
                 </a:solidFill>
               </a:rPr>
-              <a:t>Bitumen CRC और Consumption Statement वह documentary chain है जो prove करती है कि
-bitumen genuinely खरीदी, deliver और use हुई। इनके absent होने पर auditor के पास
-केवल abstract figure है — 'X MT bitumen used' — जिसे न prove किया जा सकता, न
-disprove।</a:t>
+              <a:t>Bitumen CRC और Consumption Statement — documentary chain। Absent होने पर
+auditor के पास केवल abstract figure। Verification impossible।</a:t>
             </a:r>
           </a:p>
         </p:txBody>
@@ -8275,8 +8276,8 @@
         </p:nvSpPr>
         <p:spPr>
           <a:xfrm>
-            <a:off x="6217920" y="1280160"/>
-            <a:ext cx="5669280" cy="5029200"/>
+            <a:off x="6217920" y="1234440"/>
+            <a:ext cx="5669280" cy="5120640"/>
           </a:xfrm>
           <a:prstGeom prst="rect">
             <a:avLst/>
@@ -8291,16 +8292,15 @@
           <a:p>
             <a:pPr algn="l"/>
             <a:r>
-              <a:rPr sz="1050" b="0" i="1">
-                <a:solidFill>
-                  <a:srgbClr val="AAB9C3"/>
+              <a:rPr sz="1000" b="0" i="1">
+                <a:solidFill>
+                  <a:srgbClr val="A8B9C3"/>
                 </a:solidFill>
               </a:rPr>
-              <a:t>Bitumen CRC (Consignment Receipt Certificate) and Consumption Statement are the
-documentary chain that proves bitumen was genuinely purchased, delivered and
-used. When missing, an auditor has only an abstract figure 'X MT bitumen used'
-with no way to prove or disprove it. CRC verification is universally identified
-as the single largest corruption vector in PWD road works.</a:t>
+              <a:t>Bitumen CRC (Consignment Receipt Certificate) and Consumption Statement form
+the documentary chain proving genuine purchase, delivery, and use. When
+absent, auditor has only an abstract figure — 'X MT bitumen used' — with no
+way to prove or disprove it.</a:t>
             </a:r>
           </a:p>
         </p:txBody>
@@ -8313,8 +8313,8 @@
         </p:nvSpPr>
         <p:spPr>
           <a:xfrm>
-            <a:off x="6035040" y="1280160"/>
-            <a:ext cx="27432" cy="5029200"/>
+            <a:off x="6035040" y="1234440"/>
+            <a:ext cx="27432" cy="5120640"/>
           </a:xfrm>
           <a:prstGeom prst="rect">
             <a:avLst/>
@@ -8356,8 +8356,8 @@
         </p:nvSpPr>
         <p:spPr>
           <a:xfrm>
-            <a:off x="10972800" y="6492240"/>
-            <a:ext cx="1097280" cy="274320"/>
+            <a:off x="10881360" y="6492240"/>
+            <a:ext cx="1188720" cy="274320"/>
           </a:xfrm>
           <a:prstGeom prst="rect">
             <a:avLst/>
@@ -8374,10 +8374,10 @@
             <a:r>
               <a:rPr sz="800" b="0" i="0">
                 <a:solidFill>
-                  <a:srgbClr val="64788C"/>
+                  <a:srgbClr val="647382"/>
                 </a:solidFill>
               </a:rPr>
-              <a:t>6 / 13</a:t>
+              <a:t>Slide 6 / 13</a:t>
             </a:r>
           </a:p>
         </p:txBody>
@@ -8502,8 +8502,8 @@
         </p:nvSpPr>
         <p:spPr>
           <a:xfrm>
-            <a:off x="274320" y="164592"/>
-            <a:ext cx="1005840" cy="411480"/>
+            <a:off x="274320" y="137160"/>
+            <a:ext cx="1005840" cy="402336"/>
           </a:xfrm>
           <a:prstGeom prst="rect">
             <a:avLst/>
@@ -8545,8 +8545,8 @@
         </p:nvSpPr>
         <p:spPr>
           <a:xfrm>
-            <a:off x="274320" y="164592"/>
-            <a:ext cx="1005840" cy="411480"/>
+            <a:off x="274320" y="137160"/>
+            <a:ext cx="1005840" cy="402336"/>
           </a:xfrm>
           <a:prstGeom prst="rect">
             <a:avLst/>
@@ -8561,7 +8561,7 @@
           <a:p>
             <a:pPr algn="ctr"/>
             <a:r>
-              <a:rPr sz="1100" b="1" i="0">
+              <a:rPr sz="1000" b="1" i="0">
                 <a:solidFill>
                   <a:srgbClr val="FFFFFF"/>
                 </a:solidFill>
@@ -8579,8 +8579,8 @@
         </p:nvSpPr>
         <p:spPr>
           <a:xfrm>
-            <a:off x="1417320" y="137160"/>
-            <a:ext cx="10424160" cy="548640"/>
+            <a:off x="1417320" y="109728"/>
+            <a:ext cx="10424160" cy="530352"/>
           </a:xfrm>
           <a:prstGeom prst="rect">
             <a:avLst/>
@@ -8595,12 +8595,12 @@
           <a:p>
             <a:pPr algn="l"/>
             <a:r>
-              <a:rPr sz="1800" b="1" i="0">
+              <a:rPr sz="1700" b="1" i="0">
                 <a:solidFill>
                   <a:srgbClr val="FFFFFF"/>
                 </a:solidFill>
               </a:rPr>
-              <a:t>Fraud के चार रास्ते — Bitumen में हेराफेरी</a:t>
+              <a:t>Fraud के पाँच रास्ते — Pathway 5: एक CRC, कई Projects</a:t>
             </a:r>
           </a:p>
         </p:txBody>
@@ -8613,8 +8613,8 @@
         </p:nvSpPr>
         <p:spPr>
           <a:xfrm>
-            <a:off x="1417320" y="658368"/>
-            <a:ext cx="10424160" cy="411480"/>
+            <a:off x="1417320" y="612648"/>
+            <a:ext cx="10424160" cy="402336"/>
           </a:xfrm>
           <a:prstGeom prst="rect">
             <a:avLst/>
@@ -8629,12 +8629,12 @@
           <a:p>
             <a:pPr algn="l"/>
             <a:r>
-              <a:rPr sz="1200" b="1" i="0">
+              <a:rPr sz="1150" b="1" i="0">
                 <a:solidFill>
                   <a:srgbClr val="A0C8DC"/>
                 </a:solidFill>
               </a:rPr>
-              <a:t>Four Fraud Pathways — How Bitumen Manipulation Happens</a:t>
+              <a:t>Five Fraud Pathways — incl. Multi-Project CRC Reuse</a:t>
             </a:r>
           </a:p>
         </p:txBody>
@@ -8647,7 +8647,7 @@
         </p:nvSpPr>
         <p:spPr>
           <a:xfrm>
-            <a:off x="274320" y="1170432"/>
+            <a:off x="274320" y="1133856"/>
             <a:ext cx="11640312" cy="27432"/>
           </a:xfrm>
           <a:prstGeom prst="rect">
@@ -8690,8 +8690,8 @@
         </p:nvSpPr>
         <p:spPr>
           <a:xfrm>
-            <a:off x="274320" y="1280160"/>
-            <a:ext cx="5669280" cy="5029200"/>
+            <a:off x="274320" y="1234440"/>
+            <a:ext cx="5669280" cy="5120640"/>
           </a:xfrm>
           <a:prstGeom prst="rect">
             <a:avLst/>
@@ -8706,14 +8706,14 @@
           <a:p>
             <a:pPr algn="l"/>
             <a:r>
-              <a:rPr sz="1100" b="0" i="0">
-                <a:solidFill>
-                  <a:srgbClr val="DCE1E6"/>
+              <a:rPr sz="1050" b="0" i="0">
+                <a:solidFill>
+                  <a:srgbClr val="DAE0E6"/>
                 </a:solidFill>
               </a:rPr>
-              <a:t>Pathway 1: Genuine CRC में quantity alter। Pathway 2: Fake/recycled CRC — same
-certificate multiple bills में। Pathway 3: Verification officer compromised।
-Pathway 4: Consumption statement inflate — 80 MT use, 120 MT claim।</a:t>
+              <a:t>P1: CRC alter। P2: Fake CRC। P3: Verification compromised। P4: 80 MT use, 120
+MT claim। P5 (नई — सबसे खतरनाक): एक CRC तीन projects में — 100 MT delivery,
+300 MT payment। Centralised CRC Registry के बिना invisible।</a:t>
             </a:r>
           </a:p>
         </p:txBody>
@@ -8726,8 +8726,8 @@
         </p:nvSpPr>
         <p:spPr>
           <a:xfrm>
-            <a:off x="6217920" y="1280160"/>
-            <a:ext cx="5669280" cy="5029200"/>
+            <a:off x="6217920" y="1234440"/>
+            <a:ext cx="5669280" cy="5120640"/>
           </a:xfrm>
           <a:prstGeom prst="rect">
             <a:avLst/>
@@ -8742,15 +8742,16 @@
           <a:p>
             <a:pPr algn="l"/>
             <a:r>
-              <a:rPr sz="1050" b="0" i="1">
-                <a:solidFill>
-                  <a:srgbClr val="AAB9C3"/>
+              <a:rPr sz="1000" b="0" i="1">
+                <a:solidFill>
+                  <a:srgbClr val="A8B9C3"/>
                 </a:solidFill>
               </a:rPr>
-              <a:t>Pathway 1: Genuine CRC manipulation (quantity altered). Pathway 2: Fake or
-recycled CRC (same certificate in multiple bills). Pathway 3: Compromised
-verification (verifying officer is in collusion). Pathway 4: Inflated
-consumption statement (80 MT used, 120 MT claimed).</a:t>
+              <a:t>P1: CRC quantity altered. P2: Fake/recycled CRC. P3: Verification officer
+compromised. P4: Inflated consumption (80 MT used, 120 MT claimed). P5 NEW
+(most dangerous): Same contractor submits same CRC across multiple projects
+simultaneously — one 100 MT delivery claimed at 3 projects = 300 MT payment.
+Invisible without a centralised statewide CRC registry.</a:t>
             </a:r>
           </a:p>
         </p:txBody>
@@ -8763,8 +8764,8 @@
         </p:nvSpPr>
         <p:spPr>
           <a:xfrm>
-            <a:off x="6035040" y="1280160"/>
-            <a:ext cx="27432" cy="5029200"/>
+            <a:off x="6035040" y="1234440"/>
+            <a:ext cx="27432" cy="5120640"/>
           </a:xfrm>
           <a:prstGeom prst="rect">
             <a:avLst/>
@@ -8806,8 +8807,8 @@
         </p:nvSpPr>
         <p:spPr>
           <a:xfrm>
-            <a:off x="10972800" y="6492240"/>
-            <a:ext cx="1097280" cy="274320"/>
+            <a:off x="10881360" y="6492240"/>
+            <a:ext cx="1188720" cy="274320"/>
           </a:xfrm>
           <a:prstGeom prst="rect">
             <a:avLst/>
@@ -8824,10 +8825,10 @@
             <a:r>
               <a:rPr sz="800" b="0" i="0">
                 <a:solidFill>
-                  <a:srgbClr val="64788C"/>
+                  <a:srgbClr val="647382"/>
                 </a:solidFill>
               </a:rPr>
-              <a:t>7 / 13</a:t>
+              <a:t>Slide 7 / 13</a:t>
             </a:r>
           </a:p>
         </p:txBody>
@@ -8952,8 +8953,8 @@
         </p:nvSpPr>
         <p:spPr>
           <a:xfrm>
-            <a:off x="274320" y="164592"/>
-            <a:ext cx="1005840" cy="411480"/>
+            <a:off x="274320" y="137160"/>
+            <a:ext cx="1005840" cy="402336"/>
           </a:xfrm>
           <a:prstGeom prst="rect">
             <a:avLst/>
@@ -8995,8 +8996,8 @@
         </p:nvSpPr>
         <p:spPr>
           <a:xfrm>
-            <a:off x="274320" y="164592"/>
-            <a:ext cx="1005840" cy="411480"/>
+            <a:off x="274320" y="137160"/>
+            <a:ext cx="1005840" cy="402336"/>
           </a:xfrm>
           <a:prstGeom prst="rect">
             <a:avLst/>
@@ -9011,7 +9012,7 @@
           <a:p>
             <a:pPr algn="ctr"/>
             <a:r>
-              <a:rPr sz="1100" b="1" i="0">
+              <a:rPr sz="1000" b="1" i="0">
                 <a:solidFill>
                   <a:srgbClr val="FFFFFF"/>
                 </a:solidFill>
@@ -9029,8 +9030,8 @@
         </p:nvSpPr>
         <p:spPr>
           <a:xfrm>
-            <a:off x="1417320" y="137160"/>
-            <a:ext cx="10424160" cy="548640"/>
+            <a:off x="1417320" y="109728"/>
+            <a:ext cx="10424160" cy="530352"/>
           </a:xfrm>
           <a:prstGeom prst="rect">
             <a:avLst/>
@@ -9045,12 +9046,12 @@
           <a:p>
             <a:pPr algn="l"/>
             <a:r>
-              <a:rPr sz="1800" b="1" i="0">
+              <a:rPr sz="1700" b="1" i="0">
                 <a:solidFill>
                   <a:srgbClr val="FFFFFF"/>
                 </a:solidFill>
               </a:rPr>
-              <a:t>सड़कें क्यों टूटती हैं — जनता का नुकसान</a:t>
+              <a:t>सड़कें क्यों टूटती हैं — जनता का असली नुकसान</a:t>
             </a:r>
           </a:p>
         </p:txBody>
@@ -9063,8 +9064,8 @@
         </p:nvSpPr>
         <p:spPr>
           <a:xfrm>
-            <a:off x="1417320" y="658368"/>
-            <a:ext cx="10424160" cy="411480"/>
+            <a:off x="1417320" y="612648"/>
+            <a:ext cx="10424160" cy="402336"/>
           </a:xfrm>
           <a:prstGeom prst="rect">
             <a:avLst/>
@@ -9079,7 +9080,7 @@
           <a:p>
             <a:pPr algn="l"/>
             <a:r>
-              <a:rPr sz="1200" b="1" i="0">
+              <a:rPr sz="1150" b="1" i="0">
                 <a:solidFill>
                   <a:srgbClr val="A0C8DC"/>
                 </a:solidFill>
@@ -9097,7 +9098,7 @@
         </p:nvSpPr>
         <p:spPr>
           <a:xfrm>
-            <a:off x="274320" y="1170432"/>
+            <a:off x="274320" y="1133856"/>
             <a:ext cx="11640312" cy="27432"/>
           </a:xfrm>
           <a:prstGeom prst="rect">
@@ -9140,8 +9141,8 @@
         </p:nvSpPr>
         <p:spPr>
           <a:xfrm>
-            <a:off x="274320" y="1280160"/>
-            <a:ext cx="5669280" cy="5029200"/>
+            <a:off x="274320" y="1234440"/>
+            <a:ext cx="5669280" cy="5120640"/>
           </a:xfrm>
           <a:prstGeom prst="rect">
             <a:avLst/>
@@ -9156,14 +9157,13 @@
           <a:p>
             <a:pPr algn="l"/>
             <a:r>
-              <a:rPr sz="1100" b="0" i="0">
-                <a:solidFill>
-                  <a:srgbClr val="DCE1E6"/>
+              <a:rPr sz="1050" b="0" i="0">
+                <a:solidFill>
+                  <a:srgbClr val="DAE0E6"/>
                 </a:solidFill>
               </a:rPr>
-              <a:t>Sub-standard bitumen से सड़कें design life से पहले टूटती हैं। 10 साल की सड़क 2-3
-साल में गड्ढों में। State पर additional maintenance खर्च। Public safety खतरे
-में। Taxpayer एक सड़क के लिए दो बार tax देता है।</a:t>
+              <a:t>Sub-standard bitumen: 10 साल की सड़क 2-3 साल में टूटती है। Double maintenance
+cost। Public safety risk। Taxpayer दो बार tax देता है।</a:t>
             </a:r>
           </a:p>
         </p:txBody>
@@ -9176,8 +9176,8 @@
         </p:nvSpPr>
         <p:spPr>
           <a:xfrm>
-            <a:off x="6217920" y="1280160"/>
-            <a:ext cx="5669280" cy="5029200"/>
+            <a:off x="6217920" y="1234440"/>
+            <a:ext cx="5669280" cy="5120640"/>
           </a:xfrm>
           <a:prstGeom prst="rect">
             <a:avLst/>
@@ -9192,16 +9192,15 @@
           <a:p>
             <a:pPr algn="l"/>
             <a:r>
-              <a:rPr sz="1050" b="0" i="1">
-                <a:solidFill>
-                  <a:srgbClr val="AAB9C3"/>
+              <a:rPr sz="1000" b="0" i="1">
+                <a:solidFill>
+                  <a:srgbClr val="A8B9C3"/>
                 </a:solidFill>
               </a:rPr>
-              <a:t>Sub-standard bitumen produces roads that fail years before their design life. A
-road designed for 10 years fails in 2-3. This imposes higher maintenance costs
-on the state, endagers public safety through potholes and accidents, and forces
-taxpayers to fund the same road twice. When the digital system designed to
-prevent this becomes a vehicle for concealment, the reform loses credibility.</a:t>
+              <a:t>Sub-standard bitumen: roads fail years before design life. A 10-year road
+lasts 2-3 years. Higher maintenance costs on state. Public safety endangered.
+Taxpayer funds the same road twice. When digital system designed to prevent
+this becomes a vehicle for concealment, the reform loses all credibility.</a:t>
             </a:r>
           </a:p>
         </p:txBody>
@@ -9214,8 +9213,8 @@
         </p:nvSpPr>
         <p:spPr>
           <a:xfrm>
-            <a:off x="6035040" y="1280160"/>
-            <a:ext cx="27432" cy="5029200"/>
+            <a:off x="6035040" y="1234440"/>
+            <a:ext cx="27432" cy="5120640"/>
           </a:xfrm>
           <a:prstGeom prst="rect">
             <a:avLst/>
@@ -9257,8 +9256,8 @@
         </p:nvSpPr>
         <p:spPr>
           <a:xfrm>
-            <a:off x="10972800" y="6492240"/>
-            <a:ext cx="1097280" cy="274320"/>
+            <a:off x="10881360" y="6492240"/>
+            <a:ext cx="1188720" cy="274320"/>
           </a:xfrm>
           <a:prstGeom prst="rect">
             <a:avLst/>
@@ -9275,10 +9274,10 @@
             <a:r>
               <a:rPr sz="800" b="0" i="0">
                 <a:solidFill>
-                  <a:srgbClr val="64788C"/>
+                  <a:srgbClr val="647382"/>
                 </a:solidFill>
               </a:rPr>
-              <a:t>8 / 13</a:t>
+              <a:t>Slide 8 / 13</a:t>
             </a:r>
           </a:p>
         </p:txBody>
@@ -9403,8 +9402,8 @@
         </p:nvSpPr>
         <p:spPr>
           <a:xfrm>
-            <a:off x="274320" y="164592"/>
-            <a:ext cx="1005840" cy="411480"/>
+            <a:off x="274320" y="137160"/>
+            <a:ext cx="1005840" cy="402336"/>
           </a:xfrm>
           <a:prstGeom prst="rect">
             <a:avLst/>
@@ -9446,8 +9445,8 @@
         </p:nvSpPr>
         <p:spPr>
           <a:xfrm>
-            <a:off x="274320" y="164592"/>
-            <a:ext cx="1005840" cy="411480"/>
+            <a:off x="274320" y="137160"/>
+            <a:ext cx="1005840" cy="402336"/>
           </a:xfrm>
           <a:prstGeom prst="rect">
             <a:avLst/>
@@ -9462,7 +9461,7 @@
           <a:p>
             <a:pPr algn="ctr"/>
             <a:r>
-              <a:rPr sz="1100" b="1" i="0">
+              <a:rPr sz="1000" b="1" i="0">
                 <a:solidFill>
                   <a:srgbClr val="FFFFFF"/>
                 </a:solidFill>
@@ -9480,8 +9479,8 @@
         </p:nvSpPr>
         <p:spPr>
           <a:xfrm>
-            <a:off x="1417320" y="137160"/>
-            <a:ext cx="10424160" cy="548640"/>
+            <a:off x="1417320" y="109728"/>
+            <a:ext cx="10424160" cy="530352"/>
           </a:xfrm>
           <a:prstGeom prst="rect">
             <a:avLst/>
@@ -9496,7 +9495,7 @@
           <a:p>
             <a:pPr algn="l"/>
             <a:r>
-              <a:rPr sz="1800" b="1" i="0">
+              <a:rPr sz="1700" b="1" i="0">
                 <a:solidFill>
                   <a:srgbClr val="FFFFFF"/>
                 </a:solidFill>
@@ -9514,8 +9513,8 @@
         </p:nvSpPr>
         <p:spPr>
           <a:xfrm>
-            <a:off x="1417320" y="658368"/>
-            <a:ext cx="10424160" cy="411480"/>
+            <a:off x="1417320" y="612648"/>
+            <a:ext cx="10424160" cy="402336"/>
           </a:xfrm>
           <a:prstGeom prst="rect">
             <a:avLst/>
@@ -9530,12 +9529,12 @@
           <a:p>
             <a:pPr algn="l"/>
             <a:r>
-              <a:rPr sz="1200" b="1" i="0">
+              <a:rPr sz="1150" b="1" i="0">
                 <a:solidFill>
                   <a:srgbClr val="A0C8DC"/>
                 </a:solidFill>
               </a:rPr>
-              <a:t>15 Years Online Payments — Zero Contractor Ledger, Dormant EMD/SD/Dep-V</a:t>
+              <a:t>15 Years — Zero Contractor Ledger, Dormant EMD/SD/Dep-V</a:t>
             </a:r>
           </a:p>
         </p:txBody>
@@ -9548,7 +9547,7 @@
         </p:nvSpPr>
         <p:spPr>
           <a:xfrm>
-            <a:off x="274320" y="1170432"/>
+            <a:off x="274320" y="1133856"/>
             <a:ext cx="11640312" cy="27432"/>
           </a:xfrm>
           <a:prstGeom prst="rect">
@@ -9591,8 +9590,8 @@
         </p:nvSpPr>
         <p:spPr>
           <a:xfrm>
-            <a:off x="274320" y="1280160"/>
-            <a:ext cx="5669280" cy="5029200"/>
+            <a:off x="274320" y="1234440"/>
+            <a:ext cx="5669280" cy="5120640"/>
           </a:xfrm>
           <a:prstGeom prst="rect">
             <a:avLst/>
@@ -9607,14 +9606,14 @@
           <a:p>
             <a:pPr algn="l"/>
             <a:r>
-              <a:rPr sz="1100" b="0" i="0">
-                <a:solidFill>
-                  <a:srgbClr val="DCE1E6"/>
+              <a:rPr sz="1050" b="0" i="0">
+                <a:solidFill>
+                  <a:srgbClr val="DAE0E6"/>
                 </a:solidFill>
               </a:rPr>
-              <a:t>15 वर्ष online payment — Contractor Ledger नहीं। EMD+SD+Dep-V वर्षों तक dormant।
-e-Procurement EMD online collect — refund manual। समाधान: Digital Ledger, 31
-March auto-email, e-EMD Refund, DLP alerts।</a:t>
+              <a:t>15 वर्ष online payment — Contractor Ledger नहीं। EMD+SD+Dep-V वर्षों तक
+dormant। e-Procurement EMD online collect — refund manual। समाधान: Digital
+Ledger, 31 March auto-email, e-EMD Refund integration, DLP auto-alerts।</a:t>
             </a:r>
           </a:p>
         </p:txBody>
@@ -9627,8 +9626,8 @@
         </p:nvSpPr>
         <p:spPr>
           <a:xfrm>
-            <a:off x="6217920" y="1280160"/>
-            <a:ext cx="5669280" cy="5029200"/>
+            <a:off x="6217920" y="1234440"/>
+            <a:ext cx="5669280" cy="5120640"/>
           </a:xfrm>
           <a:prstGeom prst="rect">
             <a:avLst/>
@@ -9643,16 +9642,17 @@
           <a:p>
             <a:pPr algn="l"/>
             <a:r>
-              <a:rPr sz="1050" b="0" i="1">
-                <a:solidFill>
-                  <a:srgbClr val="AAB9C3"/>
+              <a:rPr sz="1000" b="0" i="1">
+                <a:solidFill>
+                  <a:srgbClr val="A8B9C3"/>
                 </a:solidFill>
               </a:rPr>
-              <a:t>For 15 years online contractor payment has run. Yet no Contractor Ledger exists.
-EMD, SD, Dep-V lie dormant when contractor dies, records are lost, or track
-breaks. e-Procurement collects EMD online but has no e-EMD Refund system. Fix:
-Digital Contractor Ledger, automatic 31-March annual balance email, e-EMD Refund
-integrated in e-Procurement, DLP auto-alerts.</a:t>
+              <a:t>15 years of online payments — no Contractor Ledger ever built. EMD, Security
+Deposit, Dep-V lie dormant when contractor dies, records lost, or track
+breaks. Department never volunteers to return them. e-Procurement collects EMD
+online but has no e-EMD Refund system. Fix: Digital Ledger per contractor;
+mandatory 31-March annual balance email; e-EMD Refund integrated in
+e-Procurement; DLP auto-alerts.</a:t>
             </a:r>
           </a:p>
         </p:txBody>
@@ -9665,8 +9665,8 @@
         </p:nvSpPr>
         <p:spPr>
           <a:xfrm>
-            <a:off x="6035040" y="1280160"/>
-            <a:ext cx="27432" cy="5029200"/>
+            <a:off x="6035040" y="1234440"/>
+            <a:ext cx="27432" cy="5120640"/>
           </a:xfrm>
           <a:prstGeom prst="rect">
             <a:avLst/>
@@ -9708,8 +9708,8 @@
         </p:nvSpPr>
         <p:spPr>
           <a:xfrm>
-            <a:off x="10972800" y="6492240"/>
-            <a:ext cx="1097280" cy="274320"/>
+            <a:off x="10881360" y="6492240"/>
+            <a:ext cx="1188720" cy="274320"/>
           </a:xfrm>
           <a:prstGeom prst="rect">
             <a:avLst/>
@@ -9726,10 +9726,10 @@
             <a:r>
               <a:rPr sz="800" b="0" i="0">
                 <a:solidFill>
-                  <a:srgbClr val="64788C"/>
+                  <a:srgbClr val="647382"/>
                 </a:solidFill>
               </a:rPr>
-              <a:t>9 / 13</a:t>
+              <a:t>Slide 9 / 13</a:t>
             </a:r>
           </a:p>
         </p:txBody>

</xml_diff>